<commit_message>
Docs: deck, design doc and diagrams match what is built; gate adoption guide
Slide 7 said 573 kgCO2e/yr "avoided" by three fixes; the run proposes
608 from four PRs, none merged. Slide 4 showed LLM scan planning, which
is not built. AGENT_DESIGN described resume, a live grid, live PRs and
rejection learning as working, and the architecture diagrams showed
designed-only parts with no mark; they now carry a "designed" tag.

USING_THE_GATE explains how the gate runs on one PR and what another
repository needs first: real repos would be "not evaluated" today
without dummy credentials and local-only HCL. Judges read these before
the code.

Co-Authored-By: Claude Opus 5.5 <noreply@anthropic.com>
</commit_message>
<xml_diff>
--- a/docs/EmissionGate-pitch.pptx
+++ b/docs/EmissionGate-pitch.pptx
@@ -4,6 +4,9 @@
   <p:sldMasterIdLst>
     <p:sldMasterId id="2147483648" r:id="rId1"/>
   </p:sldMasterIdLst>
+  <p:notesMasterIdLst>
+    <p:notesMasterId r:id="rId12"/>
+  </p:notesMasterIdLst>
   <p:sldIdLst>
     <p:sldId id="256" r:id="rId2"/>
     <p:sldId id="257" r:id="rId3"/>
@@ -16,9 +19,6 @@
     <p:sldId id="264" r:id="rId10"/>
     <p:sldId id="265" r:id="rId11"/>
   </p:sldIdLst>
-  <p:notesMasterIdLst>
-    <p:notesMasterId r:id="rId12"/>
-  </p:notesMasterIdLst>
   <p:sldSz cx="12192000" cy="6858000"/>
   <p:notesSz cx="6858000" cy="12192000"/>
   <p:defaultTextStyle>
@@ -116,31 +116,31 @@
   <p:extLst>
     <p:ext uri="{521415D9-36F7-43E2-AB2F-B90AF26B5E84}">
       <p14:sectionLst xmlns:p14="http://schemas.microsoft.com/office/powerpoint/2010/main">
-        <p14:section name="Opening" id="{01825212-49ea-e5a3-f192-c1d7e48510d2}">
+        <p14:section name="Opening" id="{01825212-49EA-E5A3-F192-C1D7E48510D2}">
           <p14:sldIdLst>
             <p14:sldId id="256"/>
           </p14:sldIdLst>
         </p14:section>
-        <p14:section name="Problem and solution" id="{0e4ed436-4920-914a-dcba-108007d1d16e}">
+        <p14:section name="Problem and solution" id="{0E4ED436-4920-914A-DCBA-108007D1D16E}">
           <p14:sldIdLst>
             <p14:sldId id="257"/>
             <p14:sldId id="258"/>
           </p14:sldIdLst>
         </p14:section>
-        <p14:section name="How it works" id="{2492a70d-f51e-aad6-6952-8c973587e1b2}">
+        <p14:section name="How it works" id="{2492A70D-F51E-AAD6-6952-8C973587E1B2}">
           <p14:sldIdLst>
             <p14:sldId id="259"/>
             <p14:sldId id="260"/>
           </p14:sldIdLst>
         </p14:section>
-        <p14:section name="Methodology and results" id="{a8c336ff-e5e1-0d95-a611-20d7c5a1699c}">
+        <p14:section name="Methodology and results" id="{A8C336FF-E5E1-0D95-A611-20D7C5A1699C}">
           <p14:sldIdLst>
             <p14:sldId id="261"/>
             <p14:sldId id="262"/>
             <p14:sldId id="263"/>
           </p14:sldIdLst>
         </p14:section>
-        <p14:section name="Efficiency and roadmap" id="{859801b4-c06a-367d-d261-67244d4a23f0}">
+        <p14:section name="Efficiency and roadmap" id="{859801B4-C06A-367D-D261-67244D4A23F0}">
           <p14:sldIdLst>
             <p14:sldId id="264"/>
             <p14:sldId id="265"/>
@@ -156,9 +156,11 @@
 </file>
 
 <file path=ppt/charts/chart1.xml><?xml version="1.0" encoding="utf-8"?>
-<c:chartSpace xmlns:c="http://schemas.openxmlformats.org/drawingml/2006/chart" xmlns:a="http://schemas.openxmlformats.org/drawingml/2006/main" xmlns:r="http://schemas.openxmlformats.org/officeDocument/2006/relationships">
+<c:chartSpace xmlns:c="http://schemas.openxmlformats.org/drawingml/2006/chart" xmlns:a="http://schemas.openxmlformats.org/drawingml/2006/main" xmlns:r="http://schemas.openxmlformats.org/officeDocument/2006/relationships" xmlns:c16r2="http://schemas.microsoft.com/office/drawing/2015/06/chart">
   <c:date1904 val="0"/>
+  <c:lang val="en-US"/>
   <c:roundedCorners val="1"/>
+  <c:style val="2"/>
   <c:chart>
     <c:title>
       <c:tx>
@@ -186,7 +188,6 @@
           </a:p>
         </c:rich>
       </c:tx>
-      <c:layout/>
       <c:overlay val="0"/>
     </c:title>
     <c:autoTitleDeleted val="0"/>
@@ -205,7 +206,7 @@
               <c:strCache>
                 <c:ptCount val="1"/>
                 <c:pt idx="0">
-                  <c:v>Avoided by sweep fixes</c:v>
+                  <c:v>Proposed by sweep fixes (not merged)</c:v>
                 </c:pt>
               </c:strCache>
             </c:strRef>
@@ -217,63 +218,40 @@
             <a:effectLst/>
           </c:spPr>
           <c:invertIfNegative val="0"/>
-          <c:dLbls>
-            <c:numFmt formatCode="#,##0" sourceLinked="0"/>
-            <c:txPr>
-              <a:bodyPr/>
-              <a:lstStyle/>
-              <a:p>
-                <a:pPr>
-                  <a:defRPr b="0" i="0" strike="noStrike" sz="1200" u="none">
-                    <a:solidFill>
-                      <a:srgbClr val="000000"/>
-                    </a:solidFill>
-                    <a:latin typeface="Arial"/>
-                  </a:defRPr>
-                </a:pPr>
-              </a:p>
-            </c:txPr>
-            <c:showLegendKey val="0"/>
-            <c:showVal val="0"/>
-            <c:showCatName val="0"/>
-            <c:showSerName val="0"/>
-            <c:showPercent val="0"/>
-            <c:showBubbleSize val="0"/>
-            <c:showLeaderLines val="0"/>
-          </c:dLbls>
           <c:cat>
-            <c:multiLvlStrRef>
-              <c:f>Sheet1!$A$2:$A$6</c:f>
-              <c:multiLvlStrCache>
-                <c:ptCount val="5"/>
-                <c:lvl>
-                  <c:pt idx="0">
-                    <c:v>Sweep: schedule idle GPU fleet   −258.1</c:v>
-                  </c:pt>
-                  <c:pt idx="1">
-                    <c:v>Sweep: x86 workers → Graviton   −218.6</c:v>
-                  </c:pt>
-                  <c:pt idx="2">
-                    <c:v>Sweep: rightsize reporting DB   −96.6</c:v>
-                  </c:pt>
-                  <c:pt idx="3">
-                    <c:v>Gate: PR adds 2 × g5.2xlarge   +683.5</c:v>
-                  </c:pt>
-                  <c:pt idx="4">
-                    <c:v>Gate: PR scales 6 → 10 m5.2xlarge   +59.2</c:v>
-                  </c:pt>
-                </c:lvl>
-              </c:multiLvlStrCache>
-            </c:multiLvlStrRef>
+            <c:strRef>
+              <c:f>Sheet1!$A$2:$A$7</c:f>
+              <c:strCache>
+                <c:ptCount val="6"/>
+                <c:pt idx="0">
+                  <c:v>Sweep: schedule idle GPU fleet   −258.1</c:v>
+                </c:pt>
+                <c:pt idx="1">
+                  <c:v>Sweep: x86 workers → Graviton   −218.6</c:v>
+                </c:pt>
+                <c:pt idx="2">
+                  <c:v>Sweep: rightsize reporting DB   −96.6</c:v>
+                </c:pt>
+                <c:pt idx="3">
+                  <c:v>Sweep: schedule dev API   −34.7</c:v>
+                </c:pt>
+                <c:pt idx="4">
+                  <c:v>Gate: PR adds 2 × g5.2xlarge   +683.5</c:v>
+                </c:pt>
+                <c:pt idx="5">
+                  <c:v>Gate: PR scales 6 → 10 m5.2xlarge   +59.2</c:v>
+                </c:pt>
+              </c:strCache>
+            </c:strRef>
           </c:cat>
           <c:val>
             <c:numRef>
-              <c:f>Sheet1!$B$2:$B$6</c:f>
+              <c:f>Sheet1!$B$2:$B$7</c:f>
               <c:numCache>
                 <c:formatCode>General</c:formatCode>
-                <c:ptCount val="5"/>
+                <c:ptCount val="6"/>
                 <c:pt idx="0">
-                  <c:v>-258.1</c:v>
+                  <c:v>-258.10000000000002</c:v>
                 </c:pt>
                 <c:pt idx="1">
                   <c:v>-218.6</c:v>
@@ -282,14 +260,16 @@
                   <c:v>-96.6</c:v>
                 </c:pt>
                 <c:pt idx="3">
-                  <c:v>0</c:v>
-                </c:pt>
-                <c:pt idx="4">
-                  <c:v>0</c:v>
+                  <c:v>-34.700000000000003</c:v>
                 </c:pt>
               </c:numCache>
             </c:numRef>
           </c:val>
+          <c:extLst>
+            <c:ext xmlns:c16="http://schemas.microsoft.com/office/drawing/2014/chart" uri="{C3380CC4-5D6E-409C-BE32-E72D297353CC}">
+              <c16:uniqueId val="{00000000-588A-4F37-994A-10CC42A92622}"/>
+            </c:ext>
+          </c:extLst>
         </c:ser>
         <c:ser>
           <c:idx val="1"/>
@@ -312,109 +292,68 @@
             <a:effectLst/>
           </c:spPr>
           <c:invertIfNegative val="0"/>
-          <c:dLbls>
-            <c:numFmt formatCode="#,##0" sourceLinked="0"/>
-            <c:txPr>
-              <a:bodyPr/>
-              <a:lstStyle/>
-              <a:p>
-                <a:pPr>
-                  <a:defRPr b="0" i="0" strike="noStrike" sz="1200" u="none">
-                    <a:solidFill>
-                      <a:srgbClr val="000000"/>
-                    </a:solidFill>
-                    <a:latin typeface="Arial"/>
-                  </a:defRPr>
-                </a:pPr>
-              </a:p>
-            </c:txPr>
-            <c:showLegendKey val="0"/>
-            <c:showVal val="0"/>
-            <c:showCatName val="0"/>
-            <c:showSerName val="0"/>
-            <c:showPercent val="0"/>
-            <c:showBubbleSize val="0"/>
-            <c:showLeaderLines val="0"/>
-          </c:dLbls>
           <c:cat>
-            <c:multiLvlStrRef>
-              <c:f>Sheet1!$A$2:$A$6</c:f>
-              <c:multiLvlStrCache>
-                <c:ptCount val="5"/>
-                <c:lvl>
-                  <c:pt idx="0">
-                    <c:v>Sweep: schedule idle GPU fleet   −258.1</c:v>
-                  </c:pt>
-                  <c:pt idx="1">
-                    <c:v>Sweep: x86 workers → Graviton   −218.6</c:v>
-                  </c:pt>
-                  <c:pt idx="2">
-                    <c:v>Sweep: rightsize reporting DB   −96.6</c:v>
-                  </c:pt>
-                  <c:pt idx="3">
-                    <c:v>Gate: PR adds 2 × g5.2xlarge   +683.5</c:v>
-                  </c:pt>
-                  <c:pt idx="4">
-                    <c:v>Gate: PR scales 6 → 10 m5.2xlarge   +59.2</c:v>
-                  </c:pt>
-                </c:lvl>
-              </c:multiLvlStrCache>
-            </c:multiLvlStrRef>
+            <c:strRef>
+              <c:f>Sheet1!$A$2:$A$7</c:f>
+              <c:strCache>
+                <c:ptCount val="6"/>
+                <c:pt idx="0">
+                  <c:v>Sweep: schedule idle GPU fleet   −258.1</c:v>
+                </c:pt>
+                <c:pt idx="1">
+                  <c:v>Sweep: x86 workers → Graviton   −218.6</c:v>
+                </c:pt>
+                <c:pt idx="2">
+                  <c:v>Sweep: rightsize reporting DB   −96.6</c:v>
+                </c:pt>
+                <c:pt idx="3">
+                  <c:v>Sweep: schedule dev API   −34.7</c:v>
+                </c:pt>
+                <c:pt idx="4">
+                  <c:v>Gate: PR adds 2 × g5.2xlarge   +683.5</c:v>
+                </c:pt>
+                <c:pt idx="5">
+                  <c:v>Gate: PR scales 6 → 10 m5.2xlarge   +59.2</c:v>
+                </c:pt>
+              </c:strCache>
+            </c:strRef>
           </c:cat>
           <c:val>
             <c:numRef>
-              <c:f>Sheet1!$C$2:$C$6</c:f>
+              <c:f>Sheet1!$C$2:$C$7</c:f>
               <c:numCache>
                 <c:formatCode>General</c:formatCode>
-                <c:ptCount val="5"/>
-                <c:pt idx="0">
+                <c:ptCount val="6"/>
+                <c:pt idx="3">
                   <c:v>0</c:v>
                 </c:pt>
-                <c:pt idx="1">
-                  <c:v>0</c:v>
-                </c:pt>
-                <c:pt idx="2">
-                  <c:v>0</c:v>
-                </c:pt>
-                <c:pt idx="3">
+                <c:pt idx="4">
                   <c:v>683.5</c:v>
                 </c:pt>
-                <c:pt idx="4">
+                <c:pt idx="5">
                   <c:v>59.2</c:v>
                 </c:pt>
               </c:numCache>
             </c:numRef>
           </c:val>
+          <c:extLst>
+            <c:ext xmlns:c16="http://schemas.microsoft.com/office/drawing/2014/chart" uri="{C3380CC4-5D6E-409C-BE32-E72D297353CC}">
+              <c16:uniqueId val="{00000001-588A-4F37-994A-10CC42A92622}"/>
+            </c:ext>
+          </c:extLst>
         </c:ser>
         <c:dLbls>
-          <c:numFmt formatCode="#,##0" sourceLinked="0"/>
-          <c:txPr>
-            <a:bodyPr/>
-            <a:lstStyle/>
-            <a:p>
-              <a:pPr>
-                <a:defRPr b="0" i="0" strike="noStrike" sz="1200" u="none">
-                  <a:solidFill>
-                    <a:srgbClr val="000000"/>
-                  </a:solidFill>
-                  <a:latin typeface="Arial"/>
-                </a:defRPr>
-              </a:pPr>
-            </a:p>
-          </c:txPr>
           <c:showLegendKey val="0"/>
           <c:showVal val="0"/>
           <c:showCatName val="0"/>
           <c:showSerName val="0"/>
           <c:showPercent val="0"/>
           <c:showBubbleSize val="0"/>
-          <c:showLeaderLines val="0"/>
         </c:dLbls>
         <c:gapWidth val="60"/>
         <c:overlap val="100"/>
         <c:axId val="2094734554"/>
         <c:axId val="2094734552"/>
-        <c:axId val="2094734556"/>
       </c:barChart>
       <c:catAx>
         <c:axId val="2094734554"/>
@@ -455,6 +394,7 @@
         <c:crosses val="autoZero"/>
         <c:auto val="1"/>
         <c:lblAlgn val="ctr"/>
+        <c:lblOffset val="100"/>
         <c:noMultiLvlLbl val="1"/>
       </c:catAx>
       <c:valAx>
@@ -465,7 +405,7 @@
           <c:min val="-300"/>
         </c:scaling>
         <c:delete val="0"/>
-        <c:axPos val="b"/>
+        <c:axPos val="t"/>
         <c:majorGridlines>
           <c:spPr>
             <a:ln w="9525" cap="flat">
@@ -540,6 +480,7 @@
     </c:legend>
     <c:plotVisOnly val="1"/>
     <c:dispBlanksAs val="span"/>
+    <c:showDLblsOverMax val="1"/>
   </c:chart>
   <c:spPr>
     <a:noFill/>
@@ -576,234 +517,10 @@
           <a:chExt cx="0" cy="0"/>
         </a:xfrm>
       </p:grpSpPr>
-      <p:sp>
-        <p:nvSpPr>
-          <p:cNvPr id="2" name="Header Placeholder 1"/>
-          <p:cNvSpPr>
-            <a:spLocks noGrp="1"/>
-          </p:cNvSpPr>
-          <p:nvPr>
-            <p:ph type="hdr" sz="quarter"/>
-          </p:nvPr>
-        </p:nvSpPr>
-        <p:spPr>
-          <a:xfrm>
-            <a:off x="0" y="0"/>
-            <a:ext cx="2971800" cy="458788"/>
-          </a:xfrm>
-          <a:prstGeom prst="rect">
-            <a:avLst/>
-          </a:prstGeom>
-        </p:spPr>
-        <p:txBody>
-          <a:bodyPr vert="horz" lIns="91440" tIns="45720" rIns="91440" bIns="45720" rtlCol="0"/>
-          <a:lstStyle>
-            <a:lvl1pPr algn="l">
-              <a:defRPr sz="1200"/>
-            </a:lvl1pPr>
-          </a:lstStyle>
-          <a:p>
-            <a:endParaRPr lang="en-US"/>
-          </a:p>
-        </p:txBody>
-      </p:sp>
-      <p:sp>
-        <p:nvSpPr>
-          <p:cNvPr id="3" name="Date Placeholder 2"/>
-          <p:cNvSpPr>
-            <a:spLocks noGrp="1"/>
-          </p:cNvSpPr>
-          <p:nvPr>
-            <p:ph type="dt" idx="1"/>
-          </p:nvPr>
-        </p:nvSpPr>
-        <p:spPr>
-          <a:xfrm>
-            <a:off x="3884613" y="0"/>
-            <a:ext cx="2971800" cy="458788"/>
-          </a:xfrm>
-          <a:prstGeom prst="rect">
-            <a:avLst/>
-          </a:prstGeom>
-        </p:spPr>
-        <p:txBody>
-          <a:bodyPr vert="horz" lIns="91440" tIns="45720" rIns="91440" bIns="45720" rtlCol="0"/>
-          <a:lstStyle>
-            <a:lvl1pPr algn="r">
-              <a:defRPr sz="1200"/>
-            </a:lvl1pPr>
-          </a:lstStyle>
-          <a:p>
-            <a:fld id="{5282F153-3F37-0F45-9E97-73ACFA13230C}" type="datetimeFigureOut">
-              <a:rPr lang="en-US"/>
-              <a:t>7/23/19</a:t>
-            </a:fld>
-            <a:endParaRPr lang="en-US"/>
-          </a:p>
-        </p:txBody>
-      </p:sp>
-      <p:sp>
-        <p:nvSpPr>
-          <p:cNvPr id="4" name="Slide Image Placeholder 3"/>
-          <p:cNvSpPr>
-            <a:spLocks noGrp="1" noRot="1" noChangeAspect="1"/>
-          </p:cNvSpPr>
-          <p:nvPr>
-            <p:ph type="sldImg" idx="2"/>
-          </p:nvPr>
-        </p:nvSpPr>
-        <p:spPr>
-          <a:xfrm>
-            <a:off x="685800" y="1143000"/>
-            <a:ext cx="5486400" cy="3086100"/>
-          </a:xfrm>
-          <a:prstGeom prst="rect">
-            <a:avLst/>
-          </a:prstGeom>
-          <a:noFill/>
-          <a:ln w="12700">
-            <a:solidFill>
-              <a:prstClr val="black"/>
-            </a:solidFill>
-          </a:ln>
-        </p:spPr>
-        <p:txBody>
-          <a:bodyPr vert="horz" lIns="91440" tIns="45720" rIns="91440" bIns="45720" rtlCol="0" anchor="ctr"/>
-          <a:lstStyle/>
-          <a:p>
-            <a:endParaRPr lang="en-US"/>
-          </a:p>
-        </p:txBody>
-      </p:sp>
-      <p:sp>
-        <p:nvSpPr>
-          <p:cNvPr id="5" name="Notes Placeholder 4"/>
-          <p:cNvSpPr>
-            <a:spLocks noGrp="1"/>
-          </p:cNvSpPr>
-          <p:nvPr>
-            <p:ph type="body" sz="quarter" idx="3"/>
-          </p:nvPr>
-        </p:nvSpPr>
-        <p:spPr>
-          <a:xfrm>
-            <a:off x="685800" y="4400550"/>
-            <a:ext cx="5486400" cy="3600450"/>
-          </a:xfrm>
-          <a:prstGeom prst="rect">
-            <a:avLst/>
-          </a:prstGeom>
-        </p:spPr>
-        <p:txBody>
-          <a:bodyPr vert="horz" lIns="91440" tIns="45720" rIns="91440" bIns="45720" rtlCol="0"/>
-          <a:lstStyle/>
-          <a:p>
-            <a:pPr lvl="0"/>
-            <a:r>
-              <a:rPr lang="en-US"/>
-              <a:t>Click to edit Master text styles</a:t>
-            </a:r>
-          </a:p>
-          <a:p>
-            <a:pPr lvl="1"/>
-            <a:r>
-              <a:rPr lang="en-US"/>
-              <a:t>Second level</a:t>
-            </a:r>
-          </a:p>
-          <a:p>
-            <a:pPr lvl="2"/>
-            <a:r>
-              <a:rPr lang="en-US"/>
-              <a:t>Third level</a:t>
-            </a:r>
-          </a:p>
-          <a:p>
-            <a:pPr lvl="3"/>
-            <a:r>
-              <a:rPr lang="en-US"/>
-              <a:t>Fourth level</a:t>
-            </a:r>
-          </a:p>
-          <a:p>
-            <a:pPr lvl="4"/>
-            <a:r>
-              <a:rPr lang="en-US"/>
-              <a:t>Fifth level</a:t>
-            </a:r>
-          </a:p>
-        </p:txBody>
-      </p:sp>
-      <p:sp>
-        <p:nvSpPr>
-          <p:cNvPr id="6" name="Footer Placeholder 5"/>
-          <p:cNvSpPr>
-            <a:spLocks noGrp="1"/>
-          </p:cNvSpPr>
-          <p:nvPr>
-            <p:ph type="ftr" sz="quarter" idx="4"/>
-          </p:nvPr>
-        </p:nvSpPr>
-        <p:spPr>
-          <a:xfrm>
-            <a:off x="0" y="8685213"/>
-            <a:ext cx="2971800" cy="458787"/>
-          </a:xfrm>
-          <a:prstGeom prst="rect">
-            <a:avLst/>
-          </a:prstGeom>
-        </p:spPr>
-        <p:txBody>
-          <a:bodyPr vert="horz" lIns="91440" tIns="45720" rIns="91440" bIns="45720" rtlCol="0" anchor="b"/>
-          <a:lstStyle>
-            <a:lvl1pPr algn="l">
-              <a:defRPr sz="1200"/>
-            </a:lvl1pPr>
-          </a:lstStyle>
-          <a:p>
-            <a:endParaRPr lang="en-US"/>
-          </a:p>
-        </p:txBody>
-      </p:sp>
-      <p:sp>
-        <p:nvSpPr>
-          <p:cNvPr id="7" name="Slide Number Placeholder 6"/>
-          <p:cNvSpPr>
-            <a:spLocks noGrp="1"/>
-          </p:cNvSpPr>
-          <p:nvPr>
-            <p:ph type="sldNum" sz="quarter" idx="5"/>
-          </p:nvPr>
-        </p:nvSpPr>
-        <p:spPr>
-          <a:xfrm>
-            <a:off x="3884613" y="8685213"/>
-            <a:ext cx="2971800" cy="458787"/>
-          </a:xfrm>
-          <a:prstGeom prst="rect">
-            <a:avLst/>
-          </a:prstGeom>
-        </p:spPr>
-        <p:txBody>
-          <a:bodyPr vert="horz" lIns="91440" tIns="45720" rIns="91440" bIns="45720" rtlCol="0" anchor="b"/>
-          <a:lstStyle>
-            <a:lvl1pPr algn="r">
-              <a:defRPr sz="1200"/>
-            </a:lvl1pPr>
-          </a:lstStyle>
-          <a:p>
-            <a:fld id="{CE5E9CC1-C706-0F49-92D6-E571CC5EEA8F}" type="slidenum">
-              <a:rPr lang="en-US"/>
-              <a:t>‹#›</a:t>
-            </a:fld>
-            <a:endParaRPr lang="en-US"/>
-          </a:p>
-        </p:txBody>
-      </p:sp>
     </p:spTree>
     <p:extLst>
       <p:ext uri="{BB962C8B-B14F-4D97-AF65-F5344CB8AC3E}">
-        <p14:creationId xmlns:p14="http://schemas.microsoft.com/office/powerpoint/2010/main" val="1024086991"/>
+        <p14:creationId xmlns:p14="http://schemas.microsoft.com/office/powerpoint/2010/main" val="731352378"/>
       </p:ext>
     </p:extLst>
   </p:cSld>
@@ -951,7 +668,6 @@
               <a:rPr lang="en-US" dirty="0"/>
               <a:t>EmissionGate puts carbon where infrastructure decisions are actually made: the pull request. The card on the right is the real comment the gate posts on a PR that adds two GPU instances.</a:t>
             </a:r>
-            <a:endParaRPr lang="en-US" dirty="0"/>
           </a:p>
         </p:txBody>
       </p:sp>
@@ -1039,7 +755,6 @@
               <a:rPr lang="en-US" dirty="0"/>
               <a:t>The design goes further than the code; the README status table says exactly which is which. Next is evidence: the bake-off, live PRs, and calibrating the gate's assumptions against what actually deploys.</a:t>
             </a:r>
-            <a:endParaRPr lang="en-US" dirty="0"/>
           </a:p>
         </p:txBody>
       </p:sp>
@@ -1127,7 +842,6 @@
               <a:rPr lang="en-US" dirty="0"/>
               <a:t>The gap is timing and granularity. The engineer decides at the PR; carbon appears weeks later, aggregated, to someone else. Cost and carbon also rank waste differently, so cost tools are not a proxy.</a:t>
             </a:r>
-            <a:endParaRPr lang="en-US" dirty="0"/>
           </a:p>
         </p:txBody>
       </p:sp>
@@ -1213,7 +927,11 @@
           <a:p>
             <a:r>
               <a:rPr lang="en-US" dirty="0"/>
-              <a:t>One engine, two entry points. The sweep works from billing and utilisation, so its figures are observed. The gate works from a plan diff; a brand-new resource has no history, so its figure is an assumption published as a range.</a:t>
+              <a:t>One engine, two entry points. The sweep works from billing and utilisation, so its figures are observed. The gate works from a plan diff; a brand-new resource has no history, so its figure is an assumption published as a </a:t>
+            </a:r>
+            <a:r>
+              <a:rPr lang="en-US"/>
+              <a:t>range. Another repository opts in by copying one workflow file; nothing runs in the EmissionGate repo. docs/USING_THE_GATE.md follows a real PR step by step and lists what a real repository needs first.</a:t>
             </a:r>
             <a:endParaRPr lang="en-US" dirty="0"/>
           </a:p>
@@ -1303,7 +1021,6 @@
               <a:rPr lang="en-US" dirty="0"/>
               <a:t>A state machine drives thin agents. The model is only called where judgement helps, and only to choose among options the deterministic code offers. Every number comes from core, which cannot import the LLM package.</a:t>
             </a:r>
-            <a:endParaRPr lang="en-US" dirty="0"/>
           </a:p>
         </p:txBody>
       </p:sp>
@@ -1389,7 +1106,11 @@
           <a:p>
             <a:r>
               <a:rPr lang="en-US" dirty="0"/>
-              <a:t>Human oversight is mandatory in the brief. Here it is structural: the agent has no path to apply, merge, delete or spend. Rejection labels become rules in a checked-in file a human can edit.</a:t>
+              <a:t>Human oversight is mandatory in the brief. Here it is structural: the agent has no path to apply, merge, delete or spend</a:t>
+            </a:r>
+            <a:r>
+              <a:rPr lang="en-US"/>
+              <a:t>. Rejection labels are designed to become rules in a checked-in file; today a human edits that file directly.</a:t>
             </a:r>
             <a:endParaRPr lang="en-US" dirty="0"/>
           </a:p>
@@ -1479,7 +1200,6 @@
               <a:rPr lang="en-US" dirty="0"/>
               <a:t>Every figure follows the Cloud Carbon Footprint model with coefficients vendored at a pinned commit. The weakest number, utilisation of a resource that does not exist yet, is never hidden: it is published as a range and labelled.</a:t>
             </a:r>
-            <a:endParaRPr lang="en-US" dirty="0"/>
           </a:p>
         </p:txBody>
       </p:sp>
@@ -1564,10 +1284,13 @@
           <a:lstStyle/>
           <a:p>
             <a:r>
+              <a:rPr lang="en-US"/>
+              <a:t>The four sweep fix PRs would avoid 258, 219, 97 and 35 kgCO2e a year — 608 in total, proposed and not merged. </a:t>
+            </a:r>
+            <a:r>
               <a:rPr lang="en-US" dirty="0"/>
-              <a:t>The sweep fixes avoid 258, 219 and 97 kgCO2e a year. The gate's GPU example would add 684 a year at the assumed load; the scale-out PR adds 59, and its Graviton suggestion would cut 232. Archiving the compliance bucket saves money and almost no carbon, which is why ranking by carbon matters.</a:t>
-            </a:r>
-            <a:endParaRPr lang="en-US" dirty="0"/>
+              <a:t>The gate's GPU example would add 684 a year at the assumed load; the scale-out PR adds 59, and its Graviton suggestion would cut 232. Archiving the compliance bucket saves money and almost no carbon, which is why ranking by carbon matters.</a:t>
+            </a:r>
           </a:p>
         </p:txBody>
       </p:sp>
@@ -1655,7 +1378,6 @@
               <a:rPr lang="en-US" dirty="0"/>
               <a:t>We do not extrapolate to big headline numbers. The impact comes from timing and coverage: every infrastructure change is checked at the one moment it is cheapest to change.</a:t>
             </a:r>
-            <a:endParaRPr lang="en-US" dirty="0"/>
           </a:p>
         </p:txBody>
       </p:sp>
@@ -1743,7 +1465,6 @@
               <a:rPr lang="en-US" dirty="0"/>
               <a:t>The agent's own sustainability is judged, so it is measured, not claimed. The biggest saving is architectural: the model never does arithmetic and never runs in CI.</a:t>
             </a:r>
-            <a:endParaRPr lang="en-US" dirty="0"/>
           </a:p>
         </p:txBody>
       </p:sp>
@@ -1821,6 +1542,7 @@
         <a:solidFill>
           <a:schemeClr val="tx2"/>
         </a:solidFill>
+        <a:effectLst/>
       </p:bgPr>
     </p:bg>
     <p:spTree>
@@ -1840,9 +1562,11 @@
       <p:sp>
         <p:nvSpPr>
           <p:cNvPr id="2" name="Text 0"/>
-          <p:cNvSpPr/>
+          <p:cNvSpPr>
+            <a:spLocks noGrp="1"/>
+          </p:cNvSpPr>
           <p:nvPr>
-            <p:ph idx="100" type="title" hasCustomPrompt="1"/>
+            <p:ph type="title" idx="100" hasCustomPrompt="1"/>
           </p:nvPr>
         </p:nvSpPr>
         <p:spPr>
@@ -1859,7 +1583,7 @@
         <p:txBody>
           <a:bodyPr wrap="square" rtlCol="0"/>
           <a:lstStyle>
-            <a:lvl1pPr algn="l" indent="0" marL="0">
+            <a:lvl1pPr marL="0" indent="0" algn="l">
               <a:buNone/>
               <a:defRPr lang="en-US" sz="5400" b="1" dirty="0">
                 <a:solidFill>
@@ -1872,7 +1596,7 @@
             </a:lvl1pPr>
           </a:lstStyle>
           <a:p>
-            <a:pPr algn="l" indent="0" marL="0">
+            <a:pPr marL="0" indent="0" algn="l">
               <a:buNone/>
             </a:pPr>
             <a:endParaRPr lang="en-US" sz="5400" dirty="0"/>
@@ -1882,9 +1606,11 @@
       <p:sp>
         <p:nvSpPr>
           <p:cNvPr id="3" name="Text 0"/>
-          <p:cNvSpPr/>
+          <p:cNvSpPr>
+            <a:spLocks noGrp="1"/>
+          </p:cNvSpPr>
           <p:nvPr>
-            <p:ph idx="101" type="body" hasCustomPrompt="1"/>
+            <p:ph type="body" idx="101" hasCustomPrompt="1"/>
           </p:nvPr>
         </p:nvSpPr>
         <p:spPr>
@@ -1901,7 +1627,7 @@
         <p:txBody>
           <a:bodyPr wrap="square" rtlCol="0"/>
           <a:lstStyle>
-            <a:lvl1pPr algn="l" indent="0" marL="0">
+            <a:lvl1pPr marL="0" indent="0" algn="l">
               <a:buNone/>
               <a:defRPr lang="en-US" sz="2200" dirty="0">
                 <a:solidFill>
@@ -1911,7 +1637,7 @@
             </a:lvl1pPr>
           </a:lstStyle>
           <a:p>
-            <a:pPr algn="l" indent="0" marL="0">
+            <a:pPr marL="0" indent="0" algn="l">
               <a:buNone/>
             </a:pPr>
             <a:endParaRPr lang="en-US" sz="2200" dirty="0"/>
@@ -1934,6 +1660,7 @@
         <a:solidFill>
           <a:schemeClr val="bg1"/>
         </a:solidFill>
+        <a:effectLst/>
       </p:bgPr>
     </p:bg>
     <p:spTree>
@@ -1953,9 +1680,11 @@
       <p:sp>
         <p:nvSpPr>
           <p:cNvPr id="2" name="Text 0"/>
-          <p:cNvSpPr/>
+          <p:cNvSpPr>
+            <a:spLocks noGrp="1"/>
+          </p:cNvSpPr>
           <p:nvPr>
-            <p:ph idx="100" type="title" hasCustomPrompt="1"/>
+            <p:ph type="title" idx="100" hasCustomPrompt="1"/>
           </p:nvPr>
         </p:nvSpPr>
         <p:spPr>
@@ -1972,7 +1701,7 @@
         <p:txBody>
           <a:bodyPr wrap="square" rtlCol="0"/>
           <a:lstStyle>
-            <a:lvl1pPr algn="l" indent="0" marL="0">
+            <a:lvl1pPr marL="0" indent="0" algn="l">
               <a:buNone/>
               <a:defRPr lang="en-US" sz="3200" b="1" dirty="0">
                 <a:solidFill>
@@ -1985,7 +1714,7 @@
             </a:lvl1pPr>
           </a:lstStyle>
           <a:p>
-            <a:pPr algn="l" indent="0" marL="0">
+            <a:pPr marL="0" indent="0" algn="l">
               <a:buNone/>
             </a:pPr>
             <a:endParaRPr lang="en-US" sz="3200" dirty="0"/>
@@ -2013,7 +1742,7 @@
           <a:bodyPr wrap="square" lIns="0" tIns="0" rIns="0" bIns="0" rtlCol="0" anchor="ctr"/>
           <a:lstStyle/>
           <a:p>
-            <a:pPr indent="0" marL="0">
+            <a:pPr marL="0" indent="0">
               <a:buNone/>
             </a:pPr>
             <a:r>
@@ -2048,7 +1777,7 @@
           </a:prstGeom>
           <a:extLst>
             <a:ext uri="{C572A759-6A51-4108-AA02-DFA0A04FC94B}">
-              <ma14:wrappingTextBoxFlag xmlns:ma14="http://schemas.microsoft.com/office/mac/drawingml/2011/main" val="0"/>
+              <ma14:wrappingTextBoxFlag xmlns="" xmlns:ma14="http://schemas.microsoft.com/office/mac/drawingml/2011/main" val="0"/>
             </a:ext>
           </a:extLst>
         </p:spPr>
@@ -2066,8 +1795,8 @@
           <a:p>
             <a:pPr algn="r"/>
             <a:fld id="{F7021451-1387-4CA6-816F-3879F97B5CBC}" type="slidenum">
-              <a:rPr b="0" lang="en-US"/>
-              <a:t>1003</a:t>
+              <a:rPr lang="en-US" b="0"/>
+              <a:t>‹#›</a:t>
             </a:fld>
             <a:endParaRPr lang="en-US"/>
           </a:p>
@@ -2089,6 +1818,7 @@
         <a:solidFill>
           <a:schemeClr val="tx2"/>
         </a:solidFill>
+        <a:effectLst/>
       </p:bgPr>
     </p:bg>
     <p:spTree>
@@ -2108,9 +1838,11 @@
       <p:sp>
         <p:nvSpPr>
           <p:cNvPr id="2" name="Text 0"/>
-          <p:cNvSpPr/>
+          <p:cNvSpPr>
+            <a:spLocks noGrp="1"/>
+          </p:cNvSpPr>
           <p:nvPr>
-            <p:ph idx="100" type="title" hasCustomPrompt="1"/>
+            <p:ph type="title" idx="100" hasCustomPrompt="1"/>
           </p:nvPr>
         </p:nvSpPr>
         <p:spPr>
@@ -2127,7 +1859,7 @@
         <p:txBody>
           <a:bodyPr wrap="square" rtlCol="0"/>
           <a:lstStyle>
-            <a:lvl1pPr algn="l" indent="0" marL="0">
+            <a:lvl1pPr marL="0" indent="0" algn="l">
               <a:buNone/>
               <a:defRPr lang="en-US" sz="3200" b="1" dirty="0">
                 <a:solidFill>
@@ -2140,7 +1872,7 @@
             </a:lvl1pPr>
           </a:lstStyle>
           <a:p>
-            <a:pPr algn="l" indent="0" marL="0">
+            <a:pPr marL="0" indent="0" algn="l">
               <a:buNone/>
             </a:pPr>
             <a:endParaRPr lang="en-US" sz="3200" dirty="0"/>
@@ -2168,7 +1900,7 @@
           <a:bodyPr wrap="square" lIns="0" tIns="0" rIns="0" bIns="0" rtlCol="0" anchor="ctr"/>
           <a:lstStyle/>
           <a:p>
-            <a:pPr indent="0" marL="0">
+            <a:pPr marL="0" indent="0">
               <a:buNone/>
             </a:pPr>
             <a:r>
@@ -2203,7 +1935,7 @@
           </a:prstGeom>
           <a:extLst>
             <a:ext uri="{C572A759-6A51-4108-AA02-DFA0A04FC94B}">
-              <ma14:wrappingTextBoxFlag xmlns:ma14="http://schemas.microsoft.com/office/mac/drawingml/2011/main" val="0"/>
+              <ma14:wrappingTextBoxFlag xmlns="" xmlns:ma14="http://schemas.microsoft.com/office/mac/drawingml/2011/main" val="0"/>
             </a:ext>
           </a:extLst>
         </p:spPr>
@@ -2221,8 +1953,8 @@
           <a:p>
             <a:pPr algn="r"/>
             <a:fld id="{F7021451-1387-4CA6-816F-3879F97B5CBC}" type="slidenum">
-              <a:rPr b="0" lang="en-US"/>
-              <a:t>1004</a:t>
+              <a:rPr lang="en-US" b="0"/>
+              <a:t>‹#›</a:t>
             </a:fld>
             <a:endParaRPr lang="en-US"/>
           </a:p>
@@ -2239,6 +1971,11 @@
 <file path=ppt/slideMasters/slideMaster1.xml><?xml version="1.0" encoding="utf-8"?>
 <p:sldMaster xmlns:a="http://schemas.openxmlformats.org/drawingml/2006/main" xmlns:r="http://schemas.openxmlformats.org/officeDocument/2006/relationships" xmlns:p="http://schemas.openxmlformats.org/presentationml/2006/main">
   <p:cSld>
+    <p:bg>
+      <p:bgRef idx="1001">
+        <a:schemeClr val="bg1"/>
+      </p:bgRef>
+    </p:bg>
     <p:spTree>
       <p:nvGrpSpPr>
         <p:cNvPr id="1" name=""/>
@@ -2273,7 +2010,7 @@
           </a:prstGeom>
           <a:extLst>
             <a:ext uri="{C572A759-6A51-4108-AA02-DFA0A04FC94B}">
-              <ma14:wrappingTextBoxFlag xmlns:ma14="http://schemas.microsoft.com/office/mac/drawingml/2011/main" val="0"/>
+              <ma14:wrappingTextBoxFlag xmlns="" xmlns:ma14="http://schemas.microsoft.com/office/mac/drawingml/2011/main" val="0"/>
             </a:ext>
           </a:extLst>
         </p:spPr>
@@ -2291,8 +2028,8 @@
           <a:p>
             <a:pPr algn="r"/>
             <a:fld id="{F7021451-1387-4CA6-816F-3879F97B5CBC}" type="slidenum">
-              <a:rPr b="0" lang="en-US"/>
-              <a:t>null</a:t>
+              <a:rPr lang="en-US" b="0"/>
+              <a:t>‹#›</a:t>
             </a:fld>
             <a:endParaRPr lang="en-US"/>
           </a:p>
@@ -2581,9 +2318,11 @@
       <p:sp>
         <p:nvSpPr>
           <p:cNvPr id="2" name="Text 0"/>
-          <p:cNvSpPr/>
+          <p:cNvSpPr>
+            <a:spLocks noGrp="1"/>
+          </p:cNvSpPr>
           <p:nvPr>
-            <p:ph idx="100" type="title" hasCustomPrompt="1"/>
+            <p:ph type="title" idx="100" hasCustomPrompt="1"/>
           </p:nvPr>
         </p:nvSpPr>
         <p:spPr>
@@ -2601,7 +2340,7 @@
           <a:bodyPr wrap="square" lIns="0" tIns="0" rIns="0" bIns="0" rtlCol="0" anchor="b"/>
           <a:lstStyle/>
           <a:p>
-            <a:pPr algn="l" indent="0" marL="0">
+            <a:pPr marL="0" indent="0" algn="l">
               <a:buNone/>
             </a:pPr>
             <a:r>
@@ -2622,9 +2361,11 @@
       <p:sp>
         <p:nvSpPr>
           <p:cNvPr id="3" name="Text 0"/>
-          <p:cNvSpPr/>
+          <p:cNvSpPr>
+            <a:spLocks noGrp="1"/>
+          </p:cNvSpPr>
           <p:nvPr>
-            <p:ph idx="101" type="body" hasCustomPrompt="1"/>
+            <p:ph type="body" idx="101" hasCustomPrompt="1"/>
           </p:nvPr>
         </p:nvSpPr>
         <p:spPr>
@@ -2642,7 +2383,7 @@
           <a:bodyPr wrap="square" lIns="0" tIns="0" rIns="0" bIns="0" rtlCol="0" anchor="t"/>
           <a:lstStyle/>
           <a:p>
-            <a:pPr algn="l" indent="0" marL="0">
+            <a:pPr marL="0" indent="0" algn="l">
               <a:buNone/>
             </a:pPr>
             <a:r>
@@ -2678,7 +2419,7 @@
           <a:bodyPr wrap="square" lIns="0" tIns="0" rIns="0" bIns="0" rtlCol="0" anchor="t"/>
           <a:lstStyle/>
           <a:p>
-            <a:pPr indent="0" marL="0">
+            <a:pPr marL="0" indent="0">
               <a:buNone/>
             </a:pPr>
             <a:r>
@@ -2741,7 +2482,7 @@
           <a:bodyPr wrap="square" lIns="0" tIns="0" rIns="0" bIns="0" rtlCol="0" anchor="t"/>
           <a:lstStyle/>
           <a:p>
-            <a:pPr indent="0" marL="0">
+            <a:pPr marL="0" indent="0">
               <a:buNone/>
             </a:pPr>
             <a:r>
@@ -2802,7 +2543,7 @@
           <a:bodyPr wrap="square" lIns="0" tIns="0" rIns="0" bIns="0" rtlCol="0" anchor="t"/>
           <a:lstStyle/>
           <a:p>
-            <a:pPr indent="0" marL="0">
+            <a:pPr marL="0" indent="0">
               <a:buNone/>
             </a:pPr>
             <a:r>
@@ -2838,7 +2579,7 @@
           <a:bodyPr wrap="square" lIns="0" tIns="0" rIns="0" bIns="0" rtlCol="0" anchor="t"/>
           <a:lstStyle/>
           <a:p>
-            <a:pPr indent="0" marL="0">
+            <a:pPr marL="0" indent="0">
               <a:buNone/>
             </a:pPr>
             <a:r>
@@ -2855,7 +2596,7 @@
             <a:endParaRPr lang="en-US" sz="4000" dirty="0"/>
           </a:p>
           <a:p>
-            <a:pPr indent="0" marL="0">
+            <a:pPr marL="0" indent="0">
               <a:buNone/>
             </a:pPr>
             <a:r>
@@ -2869,7 +2610,7 @@
             <a:endParaRPr lang="en-US" sz="4000" dirty="0"/>
           </a:p>
           <a:p>
-            <a:pPr indent="0" marL="0">
+            <a:pPr marL="0" indent="0">
               <a:buNone/>
             </a:pPr>
             <a:r>
@@ -2883,7 +2624,7 @@
             <a:endParaRPr lang="en-US" sz="4000" dirty="0"/>
           </a:p>
           <a:p>
-            <a:pPr indent="0" marL="0">
+            <a:pPr marL="0" indent="0">
               <a:buNone/>
             </a:pPr>
             <a:r>
@@ -2900,7 +2641,7 @@
             <a:endParaRPr lang="en-US" sz="4000" dirty="0"/>
           </a:p>
           <a:p>
-            <a:pPr indent="0" marL="0">
+            <a:pPr marL="0" indent="0">
               <a:buNone/>
             </a:pPr>
             <a:r>
@@ -2943,9 +2684,11 @@
       <p:sp>
         <p:nvSpPr>
           <p:cNvPr id="2" name="Text 0"/>
-          <p:cNvSpPr/>
+          <p:cNvSpPr>
+            <a:spLocks noGrp="1"/>
+          </p:cNvSpPr>
           <p:nvPr>
-            <p:ph idx="100" type="title" hasCustomPrompt="1"/>
+            <p:ph type="title" idx="100" hasCustomPrompt="1"/>
           </p:nvPr>
         </p:nvSpPr>
         <p:spPr>
@@ -2963,7 +2706,7 @@
           <a:bodyPr wrap="square" lIns="0" tIns="0" rIns="0" bIns="0" rtlCol="0" anchor="ctr"/>
           <a:lstStyle/>
           <a:p>
-            <a:pPr algn="l" indent="0" marL="0">
+            <a:pPr marL="0" indent="0" algn="l">
               <a:buNone/>
             </a:pPr>
             <a:r>
@@ -3027,7 +2770,7 @@
           <a:bodyPr wrap="square" lIns="0" tIns="0" rIns="0" bIns="0" rtlCol="0" anchor="t"/>
           <a:lstStyle/>
           <a:p>
-            <a:pPr indent="0" marL="0">
+            <a:pPr marL="0" indent="0">
               <a:buNone/>
             </a:pPr>
             <a:r>
@@ -3182,7 +2925,7 @@
           <a:bodyPr wrap="square" lIns="0" tIns="0" rIns="0" bIns="0" rtlCol="0" anchor="t"/>
           <a:lstStyle/>
           <a:p>
-            <a:pPr indent="0" marL="0">
+            <a:pPr marL="0" indent="0">
               <a:buNone/>
             </a:pPr>
             <a:r>
@@ -3285,7 +3028,32 @@
                   <a:schemeClr val="bg1"/>
                 </a:solidFill>
               </a:rPr>
-              <a:t>Calibrate assumed loads against what deploys</a:t>
+              <a:t>Calibrate assumed loads against </a:t>
+            </a:r>
+            <a:r>
+              <a:rPr lang="en-US" sz="1500">
+                <a:solidFill>
+                  <a:schemeClr val="bg1"/>
+                </a:solidFill>
+              </a:rPr>
+              <a:t>what deploys</a:t>
+            </a:r>
+          </a:p>
+          <a:p>
+            <a:pPr marL="342900" indent="-342900">
+              <a:spcAft>
+                <a:spcPts val="1000"/>
+              </a:spcAft>
+              <a:buSzPct val="100000"/>
+              <a:buChar char="•"/>
+            </a:pPr>
+            <a:r>
+              <a:rPr lang="en-US" sz="1500">
+                <a:solidFill>
+                  <a:schemeClr val="bg1"/>
+                </a:solidFill>
+              </a:rPr>
+              <a:t>Gate on real repos: real utilisation, credential-free plans, modules</a:t>
             </a:r>
             <a:endParaRPr lang="en-US" sz="1500" dirty="0"/>
           </a:p>
@@ -3337,7 +3105,7 @@
           <a:bodyPr wrap="square" lIns="0" tIns="0" rIns="0" bIns="0" rtlCol="0" anchor="t"/>
           <a:lstStyle/>
           <a:p>
-            <a:pPr indent="0" marL="0">
+            <a:pPr marL="0" indent="0">
               <a:buNone/>
             </a:pPr>
             <a:r>
@@ -3449,7 +3217,7 @@
           <a:bodyPr wrap="square" lIns="0" tIns="0" rIns="0" bIns="0" rtlCol="0" anchor="t"/>
           <a:lstStyle/>
           <a:p>
-            <a:pPr indent="0" marL="0">
+            <a:pPr marL="0" indent="0">
               <a:buNone/>
             </a:pPr>
             <a:r>
@@ -3484,7 +3252,7 @@
           </a:prstGeom>
           <a:extLst>
             <a:ext uri="{C572A759-6A51-4108-AA02-DFA0A04FC94B}">
-              <ma14:wrappingTextBoxFlag xmlns:ma14="http://schemas.microsoft.com/office/mac/drawingml/2011/main" val="0"/>
+              <ma14:wrappingTextBoxFlag xmlns="" xmlns:ma14="http://schemas.microsoft.com/office/mac/drawingml/2011/main" val="0"/>
             </a:ext>
           </a:extLst>
         </p:spPr>
@@ -3502,7 +3270,7 @@
           <a:p>
             <a:pPr algn="r"/>
             <a:fld id="{F7021451-1387-4CA6-816F-3879F97B5CBC}" type="slidenum">
-              <a:rPr b="0" lang="en-US"/>
+              <a:rPr lang="en-US" b="0"/>
               <a:t>10</a:t>
             </a:fld>
             <a:endParaRPr lang="en-US"/>
@@ -3537,9 +3305,11 @@
       <p:sp>
         <p:nvSpPr>
           <p:cNvPr id="2" name="Text 0"/>
-          <p:cNvSpPr/>
+          <p:cNvSpPr>
+            <a:spLocks noGrp="1"/>
+          </p:cNvSpPr>
           <p:nvPr>
-            <p:ph idx="100" type="title" hasCustomPrompt="1"/>
+            <p:ph type="title" idx="100" hasCustomPrompt="1"/>
           </p:nvPr>
         </p:nvSpPr>
         <p:spPr>
@@ -3557,7 +3327,7 @@
           <a:bodyPr wrap="square" lIns="0" tIns="0" rIns="0" bIns="0" rtlCol="0" anchor="ctr"/>
           <a:lstStyle/>
           <a:p>
-            <a:pPr algn="l" indent="0" marL="0">
+            <a:pPr marL="0" indent="0" algn="l">
               <a:buNone/>
             </a:pPr>
             <a:r>
@@ -3602,14 +3372,14 @@
       </p:sp>
       <p:pic>
         <p:nvPicPr>
-          <p:cNvPr id="4" name="prob-icon-0" descr="preencoded.png">    </p:cNvPr>
+          <p:cNvPr id="4" name="prob-icon-0" descr="preencoded.png"/>
           <p:cNvPicPr>
             <a:picLocks noChangeAspect="1"/>
           </p:cNvPicPr>
           <p:nvPr/>
         </p:nvPicPr>
         <p:blipFill>
-          <a:blip r:embed="rId1"/>
+          <a:blip r:embed="rId3"/>
           <a:stretch>
             <a:fillRect/>
           </a:stretch>
@@ -3645,7 +3415,7 @@
           <a:bodyPr wrap="square" lIns="0" tIns="0" rIns="0" bIns="0" rtlCol="0" anchor="t"/>
           <a:lstStyle/>
           <a:p>
-            <a:pPr indent="0" marL="0">
+            <a:pPr marL="0" indent="0">
               <a:buNone/>
             </a:pPr>
             <a:r>
@@ -3681,7 +3451,7 @@
           <a:bodyPr wrap="square" lIns="0" tIns="0" rIns="0" bIns="0" rtlCol="0" anchor="t"/>
           <a:lstStyle/>
           <a:p>
-            <a:pPr indent="0" marL="0">
+            <a:pPr marL="0" indent="0">
               <a:buNone/>
             </a:pPr>
             <a:r>
@@ -3723,14 +3493,14 @@
       </p:sp>
       <p:pic>
         <p:nvPicPr>
-          <p:cNvPr id="8" name="prob-icon-1" descr="preencoded.png">    </p:cNvPr>
+          <p:cNvPr id="8" name="prob-icon-1" descr="preencoded.png"/>
           <p:cNvPicPr>
             <a:picLocks noChangeAspect="1"/>
           </p:cNvPicPr>
           <p:nvPr/>
         </p:nvPicPr>
         <p:blipFill>
-          <a:blip r:embed="rId2"/>
+          <a:blip r:embed="rId4"/>
           <a:stretch>
             <a:fillRect/>
           </a:stretch>
@@ -3766,7 +3536,7 @@
           <a:bodyPr wrap="square" lIns="0" tIns="0" rIns="0" bIns="0" rtlCol="0" anchor="t"/>
           <a:lstStyle/>
           <a:p>
-            <a:pPr indent="0" marL="0">
+            <a:pPr marL="0" indent="0">
               <a:buNone/>
             </a:pPr>
             <a:r>
@@ -3802,7 +3572,7 @@
           <a:bodyPr wrap="square" lIns="0" tIns="0" rIns="0" bIns="0" rtlCol="0" anchor="t"/>
           <a:lstStyle/>
           <a:p>
-            <a:pPr indent="0" marL="0">
+            <a:pPr marL="0" indent="0">
               <a:buNone/>
             </a:pPr>
             <a:r>
@@ -3844,14 +3614,14 @@
       </p:sp>
       <p:pic>
         <p:nvPicPr>
-          <p:cNvPr id="12" name="prob-icon-2" descr="preencoded.png">    </p:cNvPr>
+          <p:cNvPr id="12" name="prob-icon-2" descr="preencoded.png"/>
           <p:cNvPicPr>
             <a:picLocks noChangeAspect="1"/>
           </p:cNvPicPr>
           <p:nvPr/>
         </p:nvPicPr>
         <p:blipFill>
-          <a:blip r:embed="rId3"/>
+          <a:blip r:embed="rId5"/>
           <a:stretch>
             <a:fillRect/>
           </a:stretch>
@@ -3887,7 +3657,7 @@
           <a:bodyPr wrap="square" lIns="0" tIns="0" rIns="0" bIns="0" rtlCol="0" anchor="t"/>
           <a:lstStyle/>
           <a:p>
-            <a:pPr indent="0" marL="0">
+            <a:pPr marL="0" indent="0">
               <a:buNone/>
             </a:pPr>
             <a:r>
@@ -3923,7 +3693,7 @@
           <a:bodyPr wrap="square" lIns="0" tIns="0" rIns="0" bIns="0" rtlCol="0" anchor="t"/>
           <a:lstStyle/>
           <a:p>
-            <a:pPr indent="0" marL="0">
+            <a:pPr marL="0" indent="0">
               <a:buNone/>
             </a:pPr>
             <a:r>
@@ -3986,7 +3756,7 @@
           <a:bodyPr wrap="square" lIns="0" tIns="0" rIns="0" bIns="0" rtlCol="0" anchor="t"/>
           <a:lstStyle/>
           <a:p>
-            <a:pPr indent="0" marL="0">
+            <a:pPr marL="0" indent="0">
               <a:buNone/>
             </a:pPr>
             <a:r>
@@ -4070,7 +3840,7 @@
           <a:bodyPr wrap="square" lIns="0" tIns="0" rIns="0" bIns="0" rtlCol="0" anchor="t"/>
           <a:lstStyle/>
           <a:p>
-            <a:pPr indent="0" marL="0">
+            <a:pPr marL="0" indent="0">
               <a:buNone/>
             </a:pPr>
             <a:r>
@@ -4106,7 +3876,7 @@
           <a:bodyPr wrap="square" lIns="0" tIns="0" rIns="0" bIns="0" rtlCol="0" anchor="t"/>
           <a:lstStyle/>
           <a:p>
-            <a:pPr indent="0" marL="0">
+            <a:pPr marL="0" indent="0">
               <a:buNone/>
             </a:pPr>
             <a:r>
@@ -4167,7 +3937,7 @@
           <a:bodyPr wrap="square" lIns="0" tIns="0" rIns="0" bIns="0" rtlCol="0" anchor="t"/>
           <a:lstStyle/>
           <a:p>
-            <a:pPr indent="0" marL="0">
+            <a:pPr marL="0" indent="0">
               <a:buNone/>
             </a:pPr>
             <a:r>
@@ -4203,7 +3973,7 @@
           <a:bodyPr wrap="square" lIns="0" tIns="0" rIns="0" bIns="0" rtlCol="0" anchor="t"/>
           <a:lstStyle/>
           <a:p>
-            <a:pPr indent="0" marL="0">
+            <a:pPr marL="0" indent="0">
               <a:buNone/>
             </a:pPr>
             <a:r>
@@ -4264,7 +4034,7 @@
           <a:bodyPr wrap="square" lIns="0" tIns="0" rIns="0" bIns="0" rtlCol="0" anchor="t"/>
           <a:lstStyle/>
           <a:p>
-            <a:pPr indent="0" marL="0">
+            <a:pPr marL="0" indent="0">
               <a:buNone/>
             </a:pPr>
             <a:r>
@@ -4300,7 +4070,7 @@
           <a:bodyPr wrap="square" lIns="0" tIns="0" rIns="0" bIns="0" rtlCol="0" anchor="t"/>
           <a:lstStyle/>
           <a:p>
-            <a:pPr indent="0" marL="0">
+            <a:pPr marL="0" indent="0">
               <a:buNone/>
             </a:pPr>
             <a:r>
@@ -4361,7 +4131,7 @@
           <a:bodyPr wrap="square" lIns="0" tIns="0" rIns="0" bIns="0" rtlCol="0" anchor="t"/>
           <a:lstStyle/>
           <a:p>
-            <a:pPr indent="0" marL="0">
+            <a:pPr marL="0" indent="0">
               <a:buNone/>
             </a:pPr>
             <a:r>
@@ -4397,7 +4167,7 @@
           <a:bodyPr wrap="square" lIns="0" tIns="0" rIns="0" bIns="0" rtlCol="0" anchor="t"/>
           <a:lstStyle/>
           <a:p>
-            <a:pPr indent="0" marL="0">
+            <a:pPr marL="0" indent="0">
               <a:buNone/>
             </a:pPr>
             <a:r>
@@ -4414,7 +4184,7 @@
       </p:sp>
       <p:sp>
         <p:nvSpPr>
-          <p:cNvPr id="25" name="Slide Number Placeholder 0"/>
+          <p:cNvPr id="30" name="Slide Number Placeholder 0"/>
           <p:cNvSpPr>
             <a:spLocks noGrp="1"/>
           </p:cNvSpPr>
@@ -4432,7 +4202,7 @@
           </a:prstGeom>
           <a:extLst>
             <a:ext uri="{C572A759-6A51-4108-AA02-DFA0A04FC94B}">
-              <ma14:wrappingTextBoxFlag xmlns:ma14="http://schemas.microsoft.com/office/mac/drawingml/2011/main" val="0"/>
+              <ma14:wrappingTextBoxFlag xmlns="" xmlns:ma14="http://schemas.microsoft.com/office/mac/drawingml/2011/main" val="0"/>
             </a:ext>
           </a:extLst>
         </p:spPr>
@@ -4450,7 +4220,7 @@
           <a:p>
             <a:pPr algn="r"/>
             <a:fld id="{F7021451-1387-4CA6-816F-3879F97B5CBC}" type="slidenum">
-              <a:rPr b="0" lang="en-US"/>
+              <a:rPr lang="en-US" b="0"/>
               <a:t>2</a:t>
             </a:fld>
             <a:endParaRPr lang="en-US"/>
@@ -4485,9 +4255,11 @@
       <p:sp>
         <p:nvSpPr>
           <p:cNvPr id="2" name="Text 0"/>
-          <p:cNvSpPr/>
+          <p:cNvSpPr>
+            <a:spLocks noGrp="1"/>
+          </p:cNvSpPr>
           <p:nvPr>
-            <p:ph idx="100" type="title" hasCustomPrompt="1"/>
+            <p:ph type="title" idx="100" hasCustomPrompt="1"/>
           </p:nvPr>
         </p:nvSpPr>
         <p:spPr>
@@ -4505,7 +4277,7 @@
           <a:bodyPr wrap="square" lIns="0" tIns="0" rIns="0" bIns="0" rtlCol="0" anchor="ctr"/>
           <a:lstStyle/>
           <a:p>
-            <a:pPr algn="l" indent="0" marL="0">
+            <a:pPr marL="0" indent="0" algn="l">
               <a:buNone/>
             </a:pPr>
             <a:r>
@@ -4525,14 +4297,14 @@
       </p:sp>
       <p:pic>
         <p:nvPicPr>
-          <p:cNvPr id="3" name="overview-diagram" descr="Sweep and gate triggers feed one engine: quantifier, strategist, validator; outputs are fix PRs and PR comments">    </p:cNvPr>
+          <p:cNvPr id="3" name="overview-diagram" descr="Sweep and gate triggers feed one engine: quantifier, strategist, validator; outputs are fix PRs and PR comments"/>
           <p:cNvPicPr>
             <a:picLocks noChangeAspect="1"/>
           </p:cNvPicPr>
           <p:nvPr/>
         </p:nvPicPr>
         <p:blipFill>
-          <a:blip r:embed="rId1"/>
+          <a:blip r:embed="rId3"/>
           <a:stretch>
             <a:fillRect/>
           </a:stretch>
@@ -4595,7 +4367,7 @@
           <a:bodyPr wrap="square" lIns="0" tIns="0" rIns="0" bIns="0" rtlCol="0" anchor="t"/>
           <a:lstStyle/>
           <a:p>
-            <a:pPr indent="0" marL="0">
+            <a:pPr marL="0" indent="0">
               <a:buNone/>
             </a:pPr>
             <a:r>
@@ -4631,7 +4403,7 @@
           <a:bodyPr wrap="square" lIns="0" tIns="0" rIns="0" bIns="0" rtlCol="0" anchor="t"/>
           <a:lstStyle/>
           <a:p>
-            <a:pPr indent="0" marL="0">
+            <a:pPr marL="0" indent="0">
               <a:buNone/>
             </a:pPr>
             <a:r>
@@ -4694,7 +4466,7 @@
           <a:bodyPr wrap="square" lIns="0" tIns="0" rIns="0" bIns="0" rtlCol="0" anchor="t"/>
           <a:lstStyle/>
           <a:p>
-            <a:pPr indent="0" marL="0">
+            <a:pPr marL="0" indent="0">
               <a:buNone/>
             </a:pPr>
             <a:r>
@@ -4730,7 +4502,7 @@
           <a:bodyPr wrap="square" lIns="0" tIns="0" rIns="0" bIns="0" rtlCol="0" anchor="t"/>
           <a:lstStyle/>
           <a:p>
-            <a:pPr indent="0" marL="0">
+            <a:pPr marL="0" indent="0">
               <a:buNone/>
             </a:pPr>
             <a:r>
@@ -4739,7 +4511,15 @@
                   <a:schemeClr val="tx1"/>
                 </a:solidFill>
               </a:rPr>
-              <a:t>Checks every infrastructure PR before merge; posts the delta and validated lower-carbon suggestions.</a:t>
+              <a:t>Checks every infrastructure PR before merge; posts the delta and </a:t>
+            </a:r>
+            <a:r>
+              <a:rPr lang="en-US" sz="1400">
+                <a:solidFill>
+                  <a:schemeClr val="tx1"/>
+                </a:solidFill>
+              </a:rPr>
+              <a:t>validated lower-carbon suggestions. A repo opts in by adding one workflow file.</a:t>
             </a:r>
             <a:endParaRPr lang="en-US" sz="1400" dirty="0"/>
           </a:p>
@@ -4793,7 +4573,7 @@
           <a:bodyPr wrap="square" lIns="0" tIns="0" rIns="0" bIns="0" rtlCol="0" anchor="t"/>
           <a:lstStyle/>
           <a:p>
-            <a:pPr indent="0" marL="0">
+            <a:pPr marL="0" indent="0">
               <a:buNone/>
             </a:pPr>
             <a:r>
@@ -4829,7 +4609,7 @@
           <a:bodyPr wrap="square" lIns="0" tIns="0" rIns="0" bIns="0" rtlCol="0" anchor="t"/>
           <a:lstStyle/>
           <a:p>
-            <a:pPr indent="0" marL="0">
+            <a:pPr marL="0" indent="0">
               <a:buNone/>
             </a:pPr>
             <a:r>
@@ -4864,7 +4644,7 @@
           </a:prstGeom>
           <a:extLst>
             <a:ext uri="{C572A759-6A51-4108-AA02-DFA0A04FC94B}">
-              <ma14:wrappingTextBoxFlag xmlns:ma14="http://schemas.microsoft.com/office/mac/drawingml/2011/main" val="0"/>
+              <ma14:wrappingTextBoxFlag xmlns="" xmlns:ma14="http://schemas.microsoft.com/office/mac/drawingml/2011/main" val="0"/>
             </a:ext>
           </a:extLst>
         </p:spPr>
@@ -4882,7 +4662,7 @@
           <a:p>
             <a:pPr algn="r"/>
             <a:fld id="{F7021451-1387-4CA6-816F-3879F97B5CBC}" type="slidenum">
-              <a:rPr b="0" lang="en-US"/>
+              <a:rPr lang="en-US" b="0"/>
               <a:t>3</a:t>
             </a:fld>
             <a:endParaRPr lang="en-US"/>
@@ -4917,9 +4697,11 @@
       <p:sp>
         <p:nvSpPr>
           <p:cNvPr id="2" name="Text 0"/>
-          <p:cNvSpPr/>
+          <p:cNvSpPr>
+            <a:spLocks noGrp="1"/>
+          </p:cNvSpPr>
           <p:nvPr>
-            <p:ph idx="100" type="title" hasCustomPrompt="1"/>
+            <p:ph type="title" idx="100" hasCustomPrompt="1"/>
           </p:nvPr>
         </p:nvSpPr>
         <p:spPr>
@@ -4937,7 +4719,7 @@
           <a:bodyPr wrap="square" lIns="0" tIns="0" rIns="0" bIns="0" rtlCol="0" anchor="ctr"/>
           <a:lstStyle/>
           <a:p>
-            <a:pPr algn="l" indent="0" marL="0">
+            <a:pPr marL="0" indent="0" algn="l">
               <a:buNone/>
             </a:pPr>
             <a:r>
@@ -5003,7 +4785,7 @@
           <a:bodyPr wrap="square" lIns="0" tIns="0" rIns="0" bIns="0" rtlCol="0" anchor="ctr"/>
           <a:lstStyle/>
           <a:p>
-            <a:pPr algn="ctr" indent="0" marL="0">
+            <a:pPr marL="0" indent="0" algn="ctr">
               <a:buNone/>
             </a:pPr>
             <a:r>
@@ -5039,7 +4821,7 @@
           <a:bodyPr wrap="square" lIns="0" tIns="0" rIns="0" bIns="0" rtlCol="0" anchor="t"/>
           <a:lstStyle/>
           <a:p>
-            <a:pPr algn="ctr" indent="0" marL="0">
+            <a:pPr marL="0" indent="0" algn="ctr">
               <a:buNone/>
             </a:pPr>
             <a:r>
@@ -5063,6 +4845,312 @@
         <p:spPr>
           <a:xfrm>
             <a:off x="1947672" y="1463040"/>
+            <a:ext cx="1261872" cy="914400"/>
+          </a:xfrm>
+          <a:prstGeom prst="roundRect">
+            <a:avLst>
+              <a:gd name="adj" fmla="val 12000"/>
+            </a:avLst>
+          </a:prstGeom>
+          <a:solidFill>
+            <a:srgbClr val="2F5D7C"/>
+          </a:solidFill>
+          <a:ln w="12700">
+            <a:solidFill>
+              <a:srgbClr val="2F5D7C"/>
+            </a:solidFill>
+            <a:prstDash val="solid"/>
+          </a:ln>
+        </p:spPr>
+      </p:sp>
+      <p:sp>
+        <p:nvSpPr>
+          <p:cNvPr id="7" name="step-label-1"/>
+          <p:cNvSpPr txBox="1"/>
+          <p:nvPr/>
+        </p:nvSpPr>
+        <p:spPr>
+          <a:xfrm>
+            <a:off x="1993392" y="1463040"/>
+            <a:ext cx="1170432" cy="914400"/>
+          </a:xfrm>
+          <a:prstGeom prst="rect">
+            <a:avLst/>
+          </a:prstGeom>
+          <a:noFill/>
+          <a:ln/>
+          <a:extLst>
+            <a:ext uri="{909E8E84-426E-40DD-AFC4-6F175D3DCCD1}">
+              <a14:hiddenFill xmlns:a14="http://schemas.microsoft.com/office/drawing/2010/main">
+                <a:solidFill>
+                  <a:srgbClr val="FFFFFF"/>
+                </a:solidFill>
+              </a14:hiddenFill>
+            </a:ext>
+          </a:extLst>
+        </p:spPr>
+        <p:txBody>
+          <a:bodyPr wrap="square" lIns="0" tIns="0" rIns="0" bIns="0" rtlCol="0" anchor="ctr"/>
+          <a:lstStyle/>
+          <a:p>
+            <a:pPr marL="0" indent="0" algn="ctr">
+              <a:buNone/>
+            </a:pPr>
+            <a:r>
+              <a:rPr lang="en-US" sz="1500" b="1" dirty="0">
+                <a:solidFill>
+                  <a:schemeClr val="bg1"/>
+                </a:solidFill>
+              </a:rPr>
+              <a:t>Planner</a:t>
+            </a:r>
+            <a:endParaRPr lang="en-US" sz="1500" dirty="0"/>
+          </a:p>
+        </p:txBody>
+      </p:sp>
+      <p:sp>
+        <p:nvSpPr>
+          <p:cNvPr id="8" name="step-desc-1"/>
+          <p:cNvSpPr txBox="1"/>
+          <p:nvPr/>
+        </p:nvSpPr>
+        <p:spPr>
+          <a:xfrm>
+            <a:off x="1947672" y="2487168"/>
+            <a:ext cx="1261872" cy="685800"/>
+          </a:xfrm>
+          <a:prstGeom prst="rect">
+            <a:avLst/>
+          </a:prstGeom>
+          <a:noFill/>
+          <a:ln/>
+        </p:spPr>
+        <p:txBody>
+          <a:bodyPr wrap="square" lIns="0" tIns="0" rIns="0" bIns="0" rtlCol="0" anchor="t"/>
+          <a:lstStyle/>
+          <a:p>
+            <a:pPr marL="0" indent="0" algn="ctr">
+              <a:buNone/>
+            </a:pPr>
+            <a:r>
+              <a:rPr lang="en-US" sz="1100">
+                <a:solidFill>
+                  <a:schemeClr val="tx1"/>
+                </a:solidFill>
+              </a:rPr>
+              <a:t>scope · budget ceilings</a:t>
+            </a:r>
+            <a:endParaRPr lang="en-US" sz="1100" dirty="0"/>
+          </a:p>
+        </p:txBody>
+      </p:sp>
+      <p:sp>
+        <p:nvSpPr>
+          <p:cNvPr id="9" name="step-2"/>
+          <p:cNvSpPr/>
+          <p:nvPr/>
+        </p:nvSpPr>
+        <p:spPr>
+          <a:xfrm>
+            <a:off x="3346704" y="1463040"/>
+            <a:ext cx="1261872" cy="914400"/>
+          </a:xfrm>
+          <a:prstGeom prst="roundRect">
+            <a:avLst>
+              <a:gd name="adj" fmla="val 12000"/>
+            </a:avLst>
+          </a:prstGeom>
+          <a:solidFill>
+            <a:schemeClr val="accent4"/>
+          </a:solidFill>
+          <a:ln w="12700">
+            <a:solidFill>
+              <a:schemeClr val="accent4"/>
+            </a:solidFill>
+            <a:prstDash val="solid"/>
+          </a:ln>
+        </p:spPr>
+      </p:sp>
+      <p:sp>
+        <p:nvSpPr>
+          <p:cNvPr id="10" name="step-label-2"/>
+          <p:cNvSpPr txBox="1"/>
+          <p:nvPr/>
+        </p:nvSpPr>
+        <p:spPr>
+          <a:xfrm>
+            <a:off x="3392424" y="1463040"/>
+            <a:ext cx="1170432" cy="914400"/>
+          </a:xfrm>
+          <a:prstGeom prst="rect">
+            <a:avLst/>
+          </a:prstGeom>
+          <a:noFill/>
+          <a:ln/>
+        </p:spPr>
+        <p:txBody>
+          <a:bodyPr wrap="square" lIns="0" tIns="0" rIns="0" bIns="0" rtlCol="0" anchor="ctr"/>
+          <a:lstStyle/>
+          <a:p>
+            <a:pPr marL="0" indent="0" algn="ctr">
+              <a:buNone/>
+            </a:pPr>
+            <a:r>
+              <a:rPr lang="en-US" sz="1500" b="1" dirty="0">
+                <a:solidFill>
+                  <a:schemeClr val="bg1"/>
+                </a:solidFill>
+              </a:rPr>
+              <a:t>Collector</a:t>
+            </a:r>
+            <a:endParaRPr lang="en-US" sz="1500" dirty="0"/>
+          </a:p>
+        </p:txBody>
+      </p:sp>
+      <p:sp>
+        <p:nvSpPr>
+          <p:cNvPr id="11" name="step-desc-2"/>
+          <p:cNvSpPr txBox="1"/>
+          <p:nvPr/>
+        </p:nvSpPr>
+        <p:spPr>
+          <a:xfrm>
+            <a:off x="3346704" y="2487168"/>
+            <a:ext cx="1261872" cy="685800"/>
+          </a:xfrm>
+          <a:prstGeom prst="rect">
+            <a:avLst/>
+          </a:prstGeom>
+          <a:noFill/>
+          <a:ln/>
+        </p:spPr>
+        <p:txBody>
+          <a:bodyPr wrap="square" lIns="0" tIns="0" rIns="0" bIns="0" rtlCol="0" anchor="t"/>
+          <a:lstStyle/>
+          <a:p>
+            <a:pPr marL="0" indent="0" algn="ctr">
+              <a:buNone/>
+            </a:pPr>
+            <a:r>
+              <a:rPr lang="en-US" sz="1100" dirty="0">
+                <a:solidFill>
+                  <a:schemeClr val="tx1"/>
+                </a:solidFill>
+              </a:rPr>
+              <a:t>billing · metrics · HCL</a:t>
+            </a:r>
+            <a:endParaRPr lang="en-US" sz="1100" dirty="0"/>
+          </a:p>
+        </p:txBody>
+      </p:sp>
+      <p:sp>
+        <p:nvSpPr>
+          <p:cNvPr id="12" name="step-3"/>
+          <p:cNvSpPr/>
+          <p:nvPr/>
+        </p:nvSpPr>
+        <p:spPr>
+          <a:xfrm>
+            <a:off x="4745736" y="1463040"/>
+            <a:ext cx="1261872" cy="914400"/>
+          </a:xfrm>
+          <a:prstGeom prst="roundRect">
+            <a:avLst>
+              <a:gd name="adj" fmla="val 12000"/>
+            </a:avLst>
+          </a:prstGeom>
+          <a:solidFill>
+            <a:schemeClr val="accent4"/>
+          </a:solidFill>
+          <a:ln w="12700">
+            <a:solidFill>
+              <a:schemeClr val="accent4"/>
+            </a:solidFill>
+            <a:prstDash val="solid"/>
+          </a:ln>
+        </p:spPr>
+      </p:sp>
+      <p:sp>
+        <p:nvSpPr>
+          <p:cNvPr id="13" name="step-label-3"/>
+          <p:cNvSpPr txBox="1"/>
+          <p:nvPr/>
+        </p:nvSpPr>
+        <p:spPr>
+          <a:xfrm>
+            <a:off x="4791456" y="1463040"/>
+            <a:ext cx="1170432" cy="914400"/>
+          </a:xfrm>
+          <a:prstGeom prst="rect">
+            <a:avLst/>
+          </a:prstGeom>
+          <a:noFill/>
+          <a:ln/>
+        </p:spPr>
+        <p:txBody>
+          <a:bodyPr wrap="square" lIns="0" tIns="0" rIns="0" bIns="0" rtlCol="0" anchor="ctr"/>
+          <a:lstStyle/>
+          <a:p>
+            <a:pPr marL="0" indent="0" algn="ctr">
+              <a:buNone/>
+            </a:pPr>
+            <a:r>
+              <a:rPr lang="en-US" sz="1500" b="1" dirty="0">
+                <a:solidFill>
+                  <a:schemeClr val="bg1"/>
+                </a:solidFill>
+              </a:rPr>
+              <a:t>Quantifier</a:t>
+            </a:r>
+            <a:endParaRPr lang="en-US" sz="1500" dirty="0"/>
+          </a:p>
+        </p:txBody>
+      </p:sp>
+      <p:sp>
+        <p:nvSpPr>
+          <p:cNvPr id="14" name="step-desc-3"/>
+          <p:cNvSpPr txBox="1"/>
+          <p:nvPr/>
+        </p:nvSpPr>
+        <p:spPr>
+          <a:xfrm>
+            <a:off x="4745736" y="2487168"/>
+            <a:ext cx="1261872" cy="685800"/>
+          </a:xfrm>
+          <a:prstGeom prst="rect">
+            <a:avLst/>
+          </a:prstGeom>
+          <a:noFill/>
+          <a:ln/>
+        </p:spPr>
+        <p:txBody>
+          <a:bodyPr wrap="square" lIns="0" tIns="0" rIns="0" bIns="0" rtlCol="0" anchor="t"/>
+          <a:lstStyle/>
+          <a:p>
+            <a:pPr marL="0" indent="0" algn="ctr">
+              <a:buNone/>
+            </a:pPr>
+            <a:r>
+              <a:rPr lang="en-US" sz="1100" dirty="0">
+                <a:solidFill>
+                  <a:schemeClr val="tx1"/>
+                </a:solidFill>
+              </a:rPr>
+              <a:t>kWh · kgCO2e · provenance</a:t>
+            </a:r>
+            <a:endParaRPr lang="en-US" sz="1100" dirty="0"/>
+          </a:p>
+        </p:txBody>
+      </p:sp>
+      <p:sp>
+        <p:nvSpPr>
+          <p:cNvPr id="15" name="step-4"/>
+          <p:cNvSpPr/>
+          <p:nvPr/>
+        </p:nvSpPr>
+        <p:spPr>
+          <a:xfrm>
+            <a:off x="6144768" y="1463040"/>
             <a:ext cx="1261872" cy="914400"/>
           </a:xfrm>
           <a:prstGeom prst="roundRect">
@@ -5083,13 +5171,13 @@
       </p:sp>
       <p:sp>
         <p:nvSpPr>
-          <p:cNvPr id="7" name="step-label-1"/>
+          <p:cNvPr id="16" name="step-label-4"/>
           <p:cNvSpPr txBox="1"/>
           <p:nvPr/>
         </p:nvSpPr>
         <p:spPr>
           <a:xfrm>
-            <a:off x="1993392" y="1463040"/>
+            <a:off x="6190488" y="1463040"/>
             <a:ext cx="1170432" cy="914400"/>
           </a:xfrm>
           <a:prstGeom prst="rect">
@@ -5102,7 +5190,7 @@
           <a:bodyPr wrap="square" lIns="0" tIns="0" rIns="0" bIns="0" rtlCol="0" anchor="ctr"/>
           <a:lstStyle/>
           <a:p>
-            <a:pPr algn="ctr" indent="0" marL="0">
+            <a:pPr marL="0" indent="0" algn="ctr">
               <a:buNone/>
             </a:pPr>
             <a:r>
@@ -5111,7 +5199,7 @@
                   <a:schemeClr val="bg1"/>
                 </a:solidFill>
               </a:rPr>
-              <a:t>Planner</a:t>
+              <a:t>Strategist</a:t>
             </a:r>
             <a:endParaRPr lang="en-US" sz="1500" dirty="0"/>
           </a:p>
@@ -5119,13 +5207,13 @@
       </p:sp>
       <p:sp>
         <p:nvSpPr>
-          <p:cNvPr id="8" name="step-desc-1"/>
+          <p:cNvPr id="17" name="step-desc-4"/>
           <p:cNvSpPr txBox="1"/>
           <p:nvPr/>
         </p:nvSpPr>
         <p:spPr>
           <a:xfrm>
-            <a:off x="1947672" y="2487168"/>
+            <a:off x="6144768" y="2487168"/>
             <a:ext cx="1261872" cy="685800"/>
           </a:xfrm>
           <a:prstGeom prst="rect">
@@ -5138,7 +5226,7 @@
           <a:bodyPr wrap="square" lIns="0" tIns="0" rIns="0" bIns="0" rtlCol="0" anchor="t"/>
           <a:lstStyle/>
           <a:p>
-            <a:pPr algn="ctr" indent="0" marL="0">
+            <a:pPr marL="0" indent="0" algn="ctr">
               <a:buNone/>
             </a:pPr>
             <a:r>
@@ -5147,7 +5235,7 @@
                   <a:schemeClr val="tx1"/>
                 </a:solidFill>
               </a:rPr>
-              <a:t>scan order within budget</a:t>
+              <a:t>guardrails · carbon rank · choose option</a:t>
             </a:r>
             <a:endParaRPr lang="en-US" sz="1100" dirty="0"/>
           </a:p>
@@ -5155,13 +5243,112 @@
       </p:sp>
       <p:sp>
         <p:nvSpPr>
-          <p:cNvPr id="9" name="step-2"/>
+          <p:cNvPr id="18" name="step-5"/>
           <p:cNvSpPr/>
           <p:nvPr/>
         </p:nvSpPr>
         <p:spPr>
           <a:xfrm>
-            <a:off x="3346704" y="1463040"/>
+            <a:off x="7543800" y="1463040"/>
+            <a:ext cx="1261872" cy="914400"/>
+          </a:xfrm>
+          <a:prstGeom prst="roundRect">
+            <a:avLst>
+              <a:gd name="adj" fmla="val 12000"/>
+            </a:avLst>
+          </a:prstGeom>
+          <a:solidFill>
+            <a:schemeClr val="accent1"/>
+          </a:solidFill>
+          <a:ln w="12700">
+            <a:solidFill>
+              <a:schemeClr val="accent1"/>
+            </a:solidFill>
+            <a:prstDash val="solid"/>
+          </a:ln>
+        </p:spPr>
+      </p:sp>
+      <p:sp>
+        <p:nvSpPr>
+          <p:cNvPr id="19" name="step-label-5"/>
+          <p:cNvSpPr txBox="1"/>
+          <p:nvPr/>
+        </p:nvSpPr>
+        <p:spPr>
+          <a:xfrm>
+            <a:off x="7589520" y="1463040"/>
+            <a:ext cx="1170432" cy="914400"/>
+          </a:xfrm>
+          <a:prstGeom prst="rect">
+            <a:avLst/>
+          </a:prstGeom>
+          <a:noFill/>
+          <a:ln/>
+        </p:spPr>
+        <p:txBody>
+          <a:bodyPr wrap="square" lIns="0" tIns="0" rIns="0" bIns="0" rtlCol="0" anchor="ctr"/>
+          <a:lstStyle/>
+          <a:p>
+            <a:pPr marL="0" indent="0" algn="ctr">
+              <a:buNone/>
+            </a:pPr>
+            <a:r>
+              <a:rPr lang="en-US" sz="1500" b="1" dirty="0">
+                <a:solidFill>
+                  <a:schemeClr val="bg1"/>
+                </a:solidFill>
+              </a:rPr>
+              <a:t>Validator</a:t>
+            </a:r>
+            <a:endParaRPr lang="en-US" sz="1500" dirty="0"/>
+          </a:p>
+        </p:txBody>
+      </p:sp>
+      <p:sp>
+        <p:nvSpPr>
+          <p:cNvPr id="20" name="step-desc-5"/>
+          <p:cNvSpPr txBox="1"/>
+          <p:nvPr/>
+        </p:nvSpPr>
+        <p:spPr>
+          <a:xfrm>
+            <a:off x="7543800" y="2487168"/>
+            <a:ext cx="1261872" cy="685800"/>
+          </a:xfrm>
+          <a:prstGeom prst="rect">
+            <a:avLst/>
+          </a:prstGeom>
+          <a:noFill/>
+          <a:ln/>
+        </p:spPr>
+        <p:txBody>
+          <a:bodyPr wrap="square" lIns="0" tIns="0" rIns="0" bIns="0" rtlCol="0" anchor="t"/>
+          <a:lstStyle/>
+          <a:p>
+            <a:pPr marL="0" indent="0" algn="ctr">
+              <a:buNone/>
+            </a:pPr>
+            <a:r>
+              <a:rPr lang="en-US" sz="1100" dirty="0">
+                <a:solidFill>
+                  <a:schemeClr val="tx1"/>
+                </a:solidFill>
+              </a:rPr>
+              <a:t>render · tofu plan · repair ≤ 3</a:t>
+            </a:r>
+            <a:endParaRPr lang="en-US" sz="1100" dirty="0"/>
+          </a:p>
+        </p:txBody>
+      </p:sp>
+      <p:sp>
+        <p:nvSpPr>
+          <p:cNvPr id="21" name="step-6"/>
+          <p:cNvSpPr/>
+          <p:nvPr/>
+        </p:nvSpPr>
+        <p:spPr>
+          <a:xfrm>
+            <a:off x="8942832" y="1463040"/>
             <a:ext cx="1261872" cy="914400"/>
           </a:xfrm>
           <a:prstGeom prst="roundRect">
@@ -5182,13 +5369,13 @@
       </p:sp>
       <p:sp>
         <p:nvSpPr>
-          <p:cNvPr id="10" name="step-label-2"/>
+          <p:cNvPr id="22" name="step-label-6"/>
           <p:cNvSpPr txBox="1"/>
           <p:nvPr/>
         </p:nvSpPr>
         <p:spPr>
           <a:xfrm>
-            <a:off x="3392424" y="1463040"/>
+            <a:off x="8988552" y="1463040"/>
             <a:ext cx="1170432" cy="914400"/>
           </a:xfrm>
           <a:prstGeom prst="rect">
@@ -5201,7 +5388,7 @@
           <a:bodyPr wrap="square" lIns="0" tIns="0" rIns="0" bIns="0" rtlCol="0" anchor="ctr"/>
           <a:lstStyle/>
           <a:p>
-            <a:pPr algn="ctr" indent="0" marL="0">
+            <a:pPr marL="0" indent="0" algn="ctr">
               <a:buNone/>
             </a:pPr>
             <a:r>
@@ -5210,7 +5397,7 @@
                   <a:schemeClr val="bg1"/>
                 </a:solidFill>
               </a:rPr>
-              <a:t>Collector</a:t>
+              <a:t>Reporter</a:t>
             </a:r>
             <a:endParaRPr lang="en-US" sz="1500" dirty="0"/>
           </a:p>
@@ -5218,13 +5405,13 @@
       </p:sp>
       <p:sp>
         <p:nvSpPr>
-          <p:cNvPr id="11" name="step-desc-2"/>
+          <p:cNvPr id="23" name="step-desc-6"/>
           <p:cNvSpPr txBox="1"/>
           <p:nvPr/>
         </p:nvSpPr>
         <p:spPr>
           <a:xfrm>
-            <a:off x="3346704" y="2487168"/>
+            <a:off x="8942832" y="2487168"/>
             <a:ext cx="1261872" cy="685800"/>
           </a:xfrm>
           <a:prstGeom prst="rect">
@@ -5237,7 +5424,7 @@
           <a:bodyPr wrap="square" lIns="0" tIns="0" rIns="0" bIns="0" rtlCol="0" anchor="t"/>
           <a:lstStyle/>
           <a:p>
-            <a:pPr algn="ctr" indent="0" marL="0">
+            <a:pPr marL="0" indent="0" algn="ctr">
               <a:buNone/>
             </a:pPr>
             <a:r>
@@ -5246,7 +5433,7 @@
                   <a:schemeClr val="tx1"/>
                 </a:solidFill>
               </a:rPr>
-              <a:t>billing · metrics · HCL</a:t>
+              <a:t>PR draft · report · own footprint</a:t>
             </a:r>
             <a:endParaRPr lang="en-US" sz="1100" dirty="0"/>
           </a:p>
@@ -5254,18 +5441,180 @@
       </p:sp>
       <p:sp>
         <p:nvSpPr>
-          <p:cNvPr id="12" name="step-3"/>
+          <p:cNvPr id="24" name="step-7"/>
           <p:cNvSpPr/>
           <p:nvPr/>
         </p:nvSpPr>
         <p:spPr>
           <a:xfrm>
-            <a:off x="4745736" y="1463040"/>
+            <a:off x="10341864" y="1463040"/>
             <a:ext cx="1261872" cy="914400"/>
           </a:xfrm>
           <a:prstGeom prst="roundRect">
             <a:avLst>
               <a:gd name="adj" fmla="val 12000"/>
+            </a:avLst>
+          </a:prstGeom>
+          <a:solidFill>
+            <a:schemeClr val="accent3"/>
+          </a:solidFill>
+          <a:ln w="12700">
+            <a:solidFill>
+              <a:schemeClr val="accent3"/>
+            </a:solidFill>
+            <a:prstDash val="solid"/>
+          </a:ln>
+        </p:spPr>
+      </p:sp>
+      <p:sp>
+        <p:nvSpPr>
+          <p:cNvPr id="25" name="step-label-7"/>
+          <p:cNvSpPr txBox="1"/>
+          <p:nvPr/>
+        </p:nvSpPr>
+        <p:spPr>
+          <a:xfrm>
+            <a:off x="10387584" y="1463040"/>
+            <a:ext cx="1170432" cy="914400"/>
+          </a:xfrm>
+          <a:prstGeom prst="rect">
+            <a:avLst/>
+          </a:prstGeom>
+          <a:noFill/>
+          <a:ln/>
+        </p:spPr>
+        <p:txBody>
+          <a:bodyPr wrap="square" lIns="0" tIns="0" rIns="0" bIns="0" rtlCol="0" anchor="ctr"/>
+          <a:lstStyle/>
+          <a:p>
+            <a:pPr marL="0" indent="0" algn="ctr">
+              <a:buNone/>
+            </a:pPr>
+            <a:r>
+              <a:rPr lang="en-US" sz="1500" b="1" dirty="0">
+                <a:solidFill>
+                  <a:schemeClr val="bg1"/>
+                </a:solidFill>
+              </a:rPr>
+              <a:t>Gate 2</a:t>
+            </a:r>
+            <a:endParaRPr lang="en-US" sz="1500" dirty="0"/>
+          </a:p>
+        </p:txBody>
+      </p:sp>
+      <p:sp>
+        <p:nvSpPr>
+          <p:cNvPr id="26" name="step-desc-7"/>
+          <p:cNvSpPr txBox="1"/>
+          <p:nvPr/>
+        </p:nvSpPr>
+        <p:spPr>
+          <a:xfrm>
+            <a:off x="10341864" y="2487168"/>
+            <a:ext cx="1261872" cy="685800"/>
+          </a:xfrm>
+          <a:prstGeom prst="rect">
+            <a:avLst/>
+          </a:prstGeom>
+          <a:noFill/>
+          <a:ln/>
+        </p:spPr>
+        <p:txBody>
+          <a:bodyPr wrap="square" lIns="0" tIns="0" rIns="0" bIns="0" rtlCol="0" anchor="t"/>
+          <a:lstStyle/>
+          <a:p>
+            <a:pPr marL="0" indent="0" algn="ctr">
+              <a:buNone/>
+            </a:pPr>
+            <a:r>
+              <a:rPr lang="en-US" sz="1100" dirty="0">
+                <a:solidFill>
+                  <a:schemeClr val="tx1"/>
+                </a:solidFill>
+              </a:rPr>
+              <a:t>merge or reject</a:t>
+            </a:r>
+            <a:endParaRPr lang="en-US" sz="1100" dirty="0"/>
+          </a:p>
+        </p:txBody>
+      </p:sp>
+      <p:sp>
+        <p:nvSpPr>
+          <p:cNvPr id="27" name="legend-sw-0"/>
+          <p:cNvSpPr/>
+          <p:nvPr/>
+        </p:nvSpPr>
+        <p:spPr>
+          <a:xfrm>
+            <a:off x="548640" y="3383280"/>
+            <a:ext cx="274320" cy="274320"/>
+          </a:xfrm>
+          <a:prstGeom prst="roundRect">
+            <a:avLst>
+              <a:gd name="adj" fmla="val 16667"/>
+            </a:avLst>
+          </a:prstGeom>
+          <a:solidFill>
+            <a:schemeClr val="accent3"/>
+          </a:solidFill>
+          <a:ln w="12700">
+            <a:solidFill>
+              <a:schemeClr val="accent3"/>
+            </a:solidFill>
+            <a:prstDash val="solid"/>
+          </a:ln>
+        </p:spPr>
+      </p:sp>
+      <p:sp>
+        <p:nvSpPr>
+          <p:cNvPr id="28" name="legend-t-0"/>
+          <p:cNvSpPr txBox="1"/>
+          <p:nvPr/>
+        </p:nvSpPr>
+        <p:spPr>
+          <a:xfrm>
+            <a:off x="932688" y="3364992"/>
+            <a:ext cx="2468880" cy="320040"/>
+          </a:xfrm>
+          <a:prstGeom prst="rect">
+            <a:avLst/>
+          </a:prstGeom>
+          <a:noFill/>
+          <a:ln/>
+        </p:spPr>
+        <p:txBody>
+          <a:bodyPr wrap="square" lIns="0" tIns="0" rIns="0" bIns="0" rtlCol="0" anchor="ctr"/>
+          <a:lstStyle/>
+          <a:p>
+            <a:pPr marL="0" indent="0">
+              <a:buNone/>
+            </a:pPr>
+            <a:r>
+              <a:rPr lang="en-US" sz="1300" dirty="0">
+                <a:solidFill>
+                  <a:schemeClr val="tx1"/>
+                </a:solidFill>
+              </a:rPr>
+              <a:t>Human decision</a:t>
+            </a:r>
+            <a:endParaRPr lang="en-US" sz="1300" dirty="0"/>
+          </a:p>
+        </p:txBody>
+      </p:sp>
+      <p:sp>
+        <p:nvSpPr>
+          <p:cNvPr id="29" name="legend-sw-1"/>
+          <p:cNvSpPr/>
+          <p:nvPr/>
+        </p:nvSpPr>
+        <p:spPr>
+          <a:xfrm>
+            <a:off x="3474720" y="3383280"/>
+            <a:ext cx="274320" cy="274320"/>
+          </a:xfrm>
+          <a:prstGeom prst="roundRect">
+            <a:avLst>
+              <a:gd name="adj" fmla="val 16667"/>
             </a:avLst>
           </a:prstGeom>
           <a:solidFill>
@@ -5281,14 +5630,14 @@
       </p:sp>
       <p:sp>
         <p:nvSpPr>
-          <p:cNvPr id="13" name="step-label-3"/>
+          <p:cNvPr id="30" name="legend-t-1"/>
           <p:cNvSpPr txBox="1"/>
           <p:nvPr/>
         </p:nvSpPr>
         <p:spPr>
           <a:xfrm>
-            <a:off x="4791456" y="1463040"/>
-            <a:ext cx="1170432" cy="914400"/>
+            <a:off x="3858768" y="3364992"/>
+            <a:ext cx="2468880" cy="320040"/>
           </a:xfrm>
           <a:prstGeom prst="rect">
             <a:avLst/>
@@ -5300,71 +5649,35 @@
           <a:bodyPr wrap="square" lIns="0" tIns="0" rIns="0" bIns="0" rtlCol="0" anchor="ctr"/>
           <a:lstStyle/>
           <a:p>
-            <a:pPr algn="ctr" indent="0" marL="0">
-              <a:buNone/>
-            </a:pPr>
-            <a:r>
-              <a:rPr lang="en-US" sz="1500" b="1" dirty="0">
-                <a:solidFill>
-                  <a:schemeClr val="bg1"/>
-                </a:solidFill>
-              </a:rPr>
-              <a:t>Quantifier</a:t>
-            </a:r>
-            <a:endParaRPr lang="en-US" sz="1500" dirty="0"/>
-          </a:p>
-        </p:txBody>
-      </p:sp>
-      <p:sp>
-        <p:nvSpPr>
-          <p:cNvPr id="14" name="step-desc-3"/>
-          <p:cNvSpPr txBox="1"/>
-          <p:nvPr/>
-        </p:nvSpPr>
-        <p:spPr>
-          <a:xfrm>
-            <a:off x="4745736" y="2487168"/>
-            <a:ext cx="1261872" cy="685800"/>
-          </a:xfrm>
-          <a:prstGeom prst="rect">
-            <a:avLst/>
-          </a:prstGeom>
-          <a:noFill/>
-          <a:ln/>
-        </p:spPr>
-        <p:txBody>
-          <a:bodyPr wrap="square" lIns="0" tIns="0" rIns="0" bIns="0" rtlCol="0" anchor="t"/>
-          <a:lstStyle/>
-          <a:p>
-            <a:pPr algn="ctr" indent="0" marL="0">
-              <a:buNone/>
-            </a:pPr>
-            <a:r>
-              <a:rPr lang="en-US" sz="1100" dirty="0">
+            <a:pPr marL="0" indent="0">
+              <a:buNone/>
+            </a:pPr>
+            <a:r>
+              <a:rPr lang="en-US" sz="1300" dirty="0">
                 <a:solidFill>
                   <a:schemeClr val="tx1"/>
                 </a:solidFill>
               </a:rPr>
-              <a:t>kWh · kgCO2e · provenance</a:t>
-            </a:r>
-            <a:endParaRPr lang="en-US" sz="1100" dirty="0"/>
-          </a:p>
-        </p:txBody>
-      </p:sp>
-      <p:sp>
-        <p:nvSpPr>
-          <p:cNvPr id="15" name="step-4"/>
+              <a:t>Deterministic code</a:t>
+            </a:r>
+            <a:endParaRPr lang="en-US" sz="1300" dirty="0"/>
+          </a:p>
+        </p:txBody>
+      </p:sp>
+      <p:sp>
+        <p:nvSpPr>
+          <p:cNvPr id="31" name="legend-sw-2"/>
           <p:cNvSpPr/>
           <p:nvPr/>
         </p:nvSpPr>
         <p:spPr>
           <a:xfrm>
-            <a:off x="6144768" y="1463040"/>
-            <a:ext cx="1261872" cy="914400"/>
+            <a:off x="6400800" y="3383280"/>
+            <a:ext cx="274320" cy="274320"/>
           </a:xfrm>
           <a:prstGeom prst="roundRect">
             <a:avLst>
-              <a:gd name="adj" fmla="val 12000"/>
+              <a:gd name="adj" fmla="val 16667"/>
             </a:avLst>
           </a:prstGeom>
           <a:solidFill>
@@ -5380,528 +5693,6 @@
       </p:sp>
       <p:sp>
         <p:nvSpPr>
-          <p:cNvPr id="16" name="step-label-4"/>
-          <p:cNvSpPr txBox="1"/>
-          <p:nvPr/>
-        </p:nvSpPr>
-        <p:spPr>
-          <a:xfrm>
-            <a:off x="6190488" y="1463040"/>
-            <a:ext cx="1170432" cy="914400"/>
-          </a:xfrm>
-          <a:prstGeom prst="rect">
-            <a:avLst/>
-          </a:prstGeom>
-          <a:noFill/>
-          <a:ln/>
-        </p:spPr>
-        <p:txBody>
-          <a:bodyPr wrap="square" lIns="0" tIns="0" rIns="0" bIns="0" rtlCol="0" anchor="ctr"/>
-          <a:lstStyle/>
-          <a:p>
-            <a:pPr algn="ctr" indent="0" marL="0">
-              <a:buNone/>
-            </a:pPr>
-            <a:r>
-              <a:rPr lang="en-US" sz="1500" b="1" dirty="0">
-                <a:solidFill>
-                  <a:schemeClr val="bg1"/>
-                </a:solidFill>
-              </a:rPr>
-              <a:t>Strategist</a:t>
-            </a:r>
-            <a:endParaRPr lang="en-US" sz="1500" dirty="0"/>
-          </a:p>
-        </p:txBody>
-      </p:sp>
-      <p:sp>
-        <p:nvSpPr>
-          <p:cNvPr id="17" name="step-desc-4"/>
-          <p:cNvSpPr txBox="1"/>
-          <p:nvPr/>
-        </p:nvSpPr>
-        <p:spPr>
-          <a:xfrm>
-            <a:off x="6144768" y="2487168"/>
-            <a:ext cx="1261872" cy="685800"/>
-          </a:xfrm>
-          <a:prstGeom prst="rect">
-            <a:avLst/>
-          </a:prstGeom>
-          <a:noFill/>
-          <a:ln/>
-        </p:spPr>
-        <p:txBody>
-          <a:bodyPr wrap="square" lIns="0" tIns="0" rIns="0" bIns="0" rtlCol="0" anchor="t"/>
-          <a:lstStyle/>
-          <a:p>
-            <a:pPr algn="ctr" indent="0" marL="0">
-              <a:buNone/>
-            </a:pPr>
-            <a:r>
-              <a:rPr lang="en-US" sz="1100" dirty="0">
-                <a:solidFill>
-                  <a:schemeClr val="tx1"/>
-                </a:solidFill>
-              </a:rPr>
-              <a:t>guardrails · carbon rank · choose option</a:t>
-            </a:r>
-            <a:endParaRPr lang="en-US" sz="1100" dirty="0"/>
-          </a:p>
-        </p:txBody>
-      </p:sp>
-      <p:sp>
-        <p:nvSpPr>
-          <p:cNvPr id="18" name="step-5"/>
-          <p:cNvSpPr/>
-          <p:nvPr/>
-        </p:nvSpPr>
-        <p:spPr>
-          <a:xfrm>
-            <a:off x="7543800" y="1463040"/>
-            <a:ext cx="1261872" cy="914400"/>
-          </a:xfrm>
-          <a:prstGeom prst="roundRect">
-            <a:avLst>
-              <a:gd name="adj" fmla="val 12000"/>
-            </a:avLst>
-          </a:prstGeom>
-          <a:solidFill>
-            <a:schemeClr val="accent1"/>
-          </a:solidFill>
-          <a:ln w="12700">
-            <a:solidFill>
-              <a:schemeClr val="accent1"/>
-            </a:solidFill>
-            <a:prstDash val="solid"/>
-          </a:ln>
-        </p:spPr>
-      </p:sp>
-      <p:sp>
-        <p:nvSpPr>
-          <p:cNvPr id="19" name="step-label-5"/>
-          <p:cNvSpPr txBox="1"/>
-          <p:nvPr/>
-        </p:nvSpPr>
-        <p:spPr>
-          <a:xfrm>
-            <a:off x="7589520" y="1463040"/>
-            <a:ext cx="1170432" cy="914400"/>
-          </a:xfrm>
-          <a:prstGeom prst="rect">
-            <a:avLst/>
-          </a:prstGeom>
-          <a:noFill/>
-          <a:ln/>
-        </p:spPr>
-        <p:txBody>
-          <a:bodyPr wrap="square" lIns="0" tIns="0" rIns="0" bIns="0" rtlCol="0" anchor="ctr"/>
-          <a:lstStyle/>
-          <a:p>
-            <a:pPr algn="ctr" indent="0" marL="0">
-              <a:buNone/>
-            </a:pPr>
-            <a:r>
-              <a:rPr lang="en-US" sz="1500" b="1" dirty="0">
-                <a:solidFill>
-                  <a:schemeClr val="bg1"/>
-                </a:solidFill>
-              </a:rPr>
-              <a:t>Validator</a:t>
-            </a:r>
-            <a:endParaRPr lang="en-US" sz="1500" dirty="0"/>
-          </a:p>
-        </p:txBody>
-      </p:sp>
-      <p:sp>
-        <p:nvSpPr>
-          <p:cNvPr id="20" name="step-desc-5"/>
-          <p:cNvSpPr txBox="1"/>
-          <p:nvPr/>
-        </p:nvSpPr>
-        <p:spPr>
-          <a:xfrm>
-            <a:off x="7543800" y="2487168"/>
-            <a:ext cx="1261872" cy="685800"/>
-          </a:xfrm>
-          <a:prstGeom prst="rect">
-            <a:avLst/>
-          </a:prstGeom>
-          <a:noFill/>
-          <a:ln/>
-        </p:spPr>
-        <p:txBody>
-          <a:bodyPr wrap="square" lIns="0" tIns="0" rIns="0" bIns="0" rtlCol="0" anchor="t"/>
-          <a:lstStyle/>
-          <a:p>
-            <a:pPr algn="ctr" indent="0" marL="0">
-              <a:buNone/>
-            </a:pPr>
-            <a:r>
-              <a:rPr lang="en-US" sz="1100" dirty="0">
-                <a:solidFill>
-                  <a:schemeClr val="tx1"/>
-                </a:solidFill>
-              </a:rPr>
-              <a:t>render · tofu plan · repair ≤ 3</a:t>
-            </a:r>
-            <a:endParaRPr lang="en-US" sz="1100" dirty="0"/>
-          </a:p>
-        </p:txBody>
-      </p:sp>
-      <p:sp>
-        <p:nvSpPr>
-          <p:cNvPr id="21" name="step-6"/>
-          <p:cNvSpPr/>
-          <p:nvPr/>
-        </p:nvSpPr>
-        <p:spPr>
-          <a:xfrm>
-            <a:off x="8942832" y="1463040"/>
-            <a:ext cx="1261872" cy="914400"/>
-          </a:xfrm>
-          <a:prstGeom prst="roundRect">
-            <a:avLst>
-              <a:gd name="adj" fmla="val 12000"/>
-            </a:avLst>
-          </a:prstGeom>
-          <a:solidFill>
-            <a:schemeClr val="accent4"/>
-          </a:solidFill>
-          <a:ln w="12700">
-            <a:solidFill>
-              <a:schemeClr val="accent4"/>
-            </a:solidFill>
-            <a:prstDash val="solid"/>
-          </a:ln>
-        </p:spPr>
-      </p:sp>
-      <p:sp>
-        <p:nvSpPr>
-          <p:cNvPr id="22" name="step-label-6"/>
-          <p:cNvSpPr txBox="1"/>
-          <p:nvPr/>
-        </p:nvSpPr>
-        <p:spPr>
-          <a:xfrm>
-            <a:off x="8988552" y="1463040"/>
-            <a:ext cx="1170432" cy="914400"/>
-          </a:xfrm>
-          <a:prstGeom prst="rect">
-            <a:avLst/>
-          </a:prstGeom>
-          <a:noFill/>
-          <a:ln/>
-        </p:spPr>
-        <p:txBody>
-          <a:bodyPr wrap="square" lIns="0" tIns="0" rIns="0" bIns="0" rtlCol="0" anchor="ctr"/>
-          <a:lstStyle/>
-          <a:p>
-            <a:pPr algn="ctr" indent="0" marL="0">
-              <a:buNone/>
-            </a:pPr>
-            <a:r>
-              <a:rPr lang="en-US" sz="1500" b="1" dirty="0">
-                <a:solidFill>
-                  <a:schemeClr val="bg1"/>
-                </a:solidFill>
-              </a:rPr>
-              <a:t>Reporter</a:t>
-            </a:r>
-            <a:endParaRPr lang="en-US" sz="1500" dirty="0"/>
-          </a:p>
-        </p:txBody>
-      </p:sp>
-      <p:sp>
-        <p:nvSpPr>
-          <p:cNvPr id="23" name="step-desc-6"/>
-          <p:cNvSpPr txBox="1"/>
-          <p:nvPr/>
-        </p:nvSpPr>
-        <p:spPr>
-          <a:xfrm>
-            <a:off x="8942832" y="2487168"/>
-            <a:ext cx="1261872" cy="685800"/>
-          </a:xfrm>
-          <a:prstGeom prst="rect">
-            <a:avLst/>
-          </a:prstGeom>
-          <a:noFill/>
-          <a:ln/>
-        </p:spPr>
-        <p:txBody>
-          <a:bodyPr wrap="square" lIns="0" tIns="0" rIns="0" bIns="0" rtlCol="0" anchor="t"/>
-          <a:lstStyle/>
-          <a:p>
-            <a:pPr algn="ctr" indent="0" marL="0">
-              <a:buNone/>
-            </a:pPr>
-            <a:r>
-              <a:rPr lang="en-US" sz="1100" dirty="0">
-                <a:solidFill>
-                  <a:schemeClr val="tx1"/>
-                </a:solidFill>
-              </a:rPr>
-              <a:t>PR draft · report · own footprint</a:t>
-            </a:r>
-            <a:endParaRPr lang="en-US" sz="1100" dirty="0"/>
-          </a:p>
-        </p:txBody>
-      </p:sp>
-      <p:sp>
-        <p:nvSpPr>
-          <p:cNvPr id="24" name="step-7"/>
-          <p:cNvSpPr/>
-          <p:nvPr/>
-        </p:nvSpPr>
-        <p:spPr>
-          <a:xfrm>
-            <a:off x="10341864" y="1463040"/>
-            <a:ext cx="1261872" cy="914400"/>
-          </a:xfrm>
-          <a:prstGeom prst="roundRect">
-            <a:avLst>
-              <a:gd name="adj" fmla="val 12000"/>
-            </a:avLst>
-          </a:prstGeom>
-          <a:solidFill>
-            <a:schemeClr val="accent3"/>
-          </a:solidFill>
-          <a:ln w="12700">
-            <a:solidFill>
-              <a:schemeClr val="accent3"/>
-            </a:solidFill>
-            <a:prstDash val="solid"/>
-          </a:ln>
-        </p:spPr>
-      </p:sp>
-      <p:sp>
-        <p:nvSpPr>
-          <p:cNvPr id="25" name="step-label-7"/>
-          <p:cNvSpPr txBox="1"/>
-          <p:nvPr/>
-        </p:nvSpPr>
-        <p:spPr>
-          <a:xfrm>
-            <a:off x="10387584" y="1463040"/>
-            <a:ext cx="1170432" cy="914400"/>
-          </a:xfrm>
-          <a:prstGeom prst="rect">
-            <a:avLst/>
-          </a:prstGeom>
-          <a:noFill/>
-          <a:ln/>
-        </p:spPr>
-        <p:txBody>
-          <a:bodyPr wrap="square" lIns="0" tIns="0" rIns="0" bIns="0" rtlCol="0" anchor="ctr"/>
-          <a:lstStyle/>
-          <a:p>
-            <a:pPr algn="ctr" indent="0" marL="0">
-              <a:buNone/>
-            </a:pPr>
-            <a:r>
-              <a:rPr lang="en-US" sz="1500" b="1" dirty="0">
-                <a:solidFill>
-                  <a:schemeClr val="bg1"/>
-                </a:solidFill>
-              </a:rPr>
-              <a:t>Gate 2</a:t>
-            </a:r>
-            <a:endParaRPr lang="en-US" sz="1500" dirty="0"/>
-          </a:p>
-        </p:txBody>
-      </p:sp>
-      <p:sp>
-        <p:nvSpPr>
-          <p:cNvPr id="26" name="step-desc-7"/>
-          <p:cNvSpPr txBox="1"/>
-          <p:nvPr/>
-        </p:nvSpPr>
-        <p:spPr>
-          <a:xfrm>
-            <a:off x="10341864" y="2487168"/>
-            <a:ext cx="1261872" cy="685800"/>
-          </a:xfrm>
-          <a:prstGeom prst="rect">
-            <a:avLst/>
-          </a:prstGeom>
-          <a:noFill/>
-          <a:ln/>
-        </p:spPr>
-        <p:txBody>
-          <a:bodyPr wrap="square" lIns="0" tIns="0" rIns="0" bIns="0" rtlCol="0" anchor="t"/>
-          <a:lstStyle/>
-          <a:p>
-            <a:pPr algn="ctr" indent="0" marL="0">
-              <a:buNone/>
-            </a:pPr>
-            <a:r>
-              <a:rPr lang="en-US" sz="1100" dirty="0">
-                <a:solidFill>
-                  <a:schemeClr val="tx1"/>
-                </a:solidFill>
-              </a:rPr>
-              <a:t>merge or reject</a:t>
-            </a:r>
-            <a:endParaRPr lang="en-US" sz="1100" dirty="0"/>
-          </a:p>
-        </p:txBody>
-      </p:sp>
-      <p:sp>
-        <p:nvSpPr>
-          <p:cNvPr id="27" name="legend-sw-0"/>
-          <p:cNvSpPr/>
-          <p:nvPr/>
-        </p:nvSpPr>
-        <p:spPr>
-          <a:xfrm>
-            <a:off x="548640" y="3383280"/>
-            <a:ext cx="274320" cy="274320"/>
-          </a:xfrm>
-          <a:prstGeom prst="roundRect">
-            <a:avLst>
-              <a:gd name="adj" fmla="val 16667"/>
-            </a:avLst>
-          </a:prstGeom>
-          <a:solidFill>
-            <a:schemeClr val="accent3"/>
-          </a:solidFill>
-          <a:ln w="12700">
-            <a:solidFill>
-              <a:schemeClr val="accent3"/>
-            </a:solidFill>
-            <a:prstDash val="solid"/>
-          </a:ln>
-        </p:spPr>
-      </p:sp>
-      <p:sp>
-        <p:nvSpPr>
-          <p:cNvPr id="28" name="legend-t-0"/>
-          <p:cNvSpPr txBox="1"/>
-          <p:nvPr/>
-        </p:nvSpPr>
-        <p:spPr>
-          <a:xfrm>
-            <a:off x="932688" y="3364992"/>
-            <a:ext cx="2468880" cy="320040"/>
-          </a:xfrm>
-          <a:prstGeom prst="rect">
-            <a:avLst/>
-          </a:prstGeom>
-          <a:noFill/>
-          <a:ln/>
-        </p:spPr>
-        <p:txBody>
-          <a:bodyPr wrap="square" lIns="0" tIns="0" rIns="0" bIns="0" rtlCol="0" anchor="ctr"/>
-          <a:lstStyle/>
-          <a:p>
-            <a:pPr indent="0" marL="0">
-              <a:buNone/>
-            </a:pPr>
-            <a:r>
-              <a:rPr lang="en-US" sz="1300" dirty="0">
-                <a:solidFill>
-                  <a:schemeClr val="tx1"/>
-                </a:solidFill>
-              </a:rPr>
-              <a:t>Human decision</a:t>
-            </a:r>
-            <a:endParaRPr lang="en-US" sz="1300" dirty="0"/>
-          </a:p>
-        </p:txBody>
-      </p:sp>
-      <p:sp>
-        <p:nvSpPr>
-          <p:cNvPr id="29" name="legend-sw-1"/>
-          <p:cNvSpPr/>
-          <p:nvPr/>
-        </p:nvSpPr>
-        <p:spPr>
-          <a:xfrm>
-            <a:off x="3474720" y="3383280"/>
-            <a:ext cx="274320" cy="274320"/>
-          </a:xfrm>
-          <a:prstGeom prst="roundRect">
-            <a:avLst>
-              <a:gd name="adj" fmla="val 16667"/>
-            </a:avLst>
-          </a:prstGeom>
-          <a:solidFill>
-            <a:schemeClr val="accent4"/>
-          </a:solidFill>
-          <a:ln w="12700">
-            <a:solidFill>
-              <a:schemeClr val="accent4"/>
-            </a:solidFill>
-            <a:prstDash val="solid"/>
-          </a:ln>
-        </p:spPr>
-      </p:sp>
-      <p:sp>
-        <p:nvSpPr>
-          <p:cNvPr id="30" name="legend-t-1"/>
-          <p:cNvSpPr txBox="1"/>
-          <p:nvPr/>
-        </p:nvSpPr>
-        <p:spPr>
-          <a:xfrm>
-            <a:off x="3858768" y="3364992"/>
-            <a:ext cx="2468880" cy="320040"/>
-          </a:xfrm>
-          <a:prstGeom prst="rect">
-            <a:avLst/>
-          </a:prstGeom>
-          <a:noFill/>
-          <a:ln/>
-        </p:spPr>
-        <p:txBody>
-          <a:bodyPr wrap="square" lIns="0" tIns="0" rIns="0" bIns="0" rtlCol="0" anchor="ctr"/>
-          <a:lstStyle/>
-          <a:p>
-            <a:pPr indent="0" marL="0">
-              <a:buNone/>
-            </a:pPr>
-            <a:r>
-              <a:rPr lang="en-US" sz="1300" dirty="0">
-                <a:solidFill>
-                  <a:schemeClr val="tx1"/>
-                </a:solidFill>
-              </a:rPr>
-              <a:t>Deterministic code</a:t>
-            </a:r>
-            <a:endParaRPr lang="en-US" sz="1300" dirty="0"/>
-          </a:p>
-        </p:txBody>
-      </p:sp>
-      <p:sp>
-        <p:nvSpPr>
-          <p:cNvPr id="31" name="legend-sw-2"/>
-          <p:cNvSpPr/>
-          <p:nvPr/>
-        </p:nvSpPr>
-        <p:spPr>
-          <a:xfrm>
-            <a:off x="6400800" y="3383280"/>
-            <a:ext cx="274320" cy="274320"/>
-          </a:xfrm>
-          <a:prstGeom prst="roundRect">
-            <a:avLst>
-              <a:gd name="adj" fmla="val 16667"/>
-            </a:avLst>
-          </a:prstGeom>
-          <a:solidFill>
-            <a:schemeClr val="accent1"/>
-          </a:solidFill>
-          <a:ln w="12700">
-            <a:solidFill>
-              <a:schemeClr val="accent1"/>
-            </a:solidFill>
-            <a:prstDash val="solid"/>
-          </a:ln>
-        </p:spPr>
-      </p:sp>
-      <p:sp>
-        <p:nvSpPr>
           <p:cNvPr id="32" name="legend-t-2"/>
           <p:cNvSpPr txBox="1"/>
           <p:nvPr/>
@@ -5921,7 +5712,7 @@
           <a:bodyPr wrap="square" lIns="0" tIns="0" rIns="0" bIns="0" rtlCol="0" anchor="ctr"/>
           <a:lstStyle/>
           <a:p>
-            <a:pPr indent="0" marL="0">
+            <a:pPr marL="0" indent="0">
               <a:buNone/>
             </a:pPr>
             <a:r>
@@ -5984,7 +5775,7 @@
           <a:bodyPr wrap="square" lIns="0" tIns="0" rIns="0" bIns="0" rtlCol="0" anchor="t"/>
           <a:lstStyle/>
           <a:p>
-            <a:pPr indent="0" marL="0">
+            <a:pPr marL="0" indent="0">
               <a:spcAft>
                 <a:spcPts val="600"/>
               </a:spcAft>
@@ -6001,7 +5792,7 @@
             <a:endParaRPr lang="en-US" sz="1700" dirty="0"/>
           </a:p>
           <a:p>
-            <a:pPr indent="0" marL="0">
+            <a:pPr marL="0" indent="0">
               <a:spcAft>
                 <a:spcPts val="600"/>
               </a:spcAft>
@@ -6018,7 +5809,7 @@
             <a:endParaRPr lang="en-US" sz="1700" dirty="0"/>
           </a:p>
           <a:p>
-            <a:pPr indent="0" marL="0">
+            <a:pPr marL="0" indent="0">
               <a:spcAft>
                 <a:spcPts val="600"/>
               </a:spcAft>
@@ -6084,7 +5875,7 @@
           <a:bodyPr wrap="square" lIns="0" tIns="0" rIns="0" bIns="0" rtlCol="0" anchor="t"/>
           <a:lstStyle/>
           <a:p>
-            <a:pPr indent="0" marL="0">
+            <a:pPr marL="0" indent="0">
               <a:spcAft>
                 <a:spcPts val="600"/>
               </a:spcAft>
@@ -6101,7 +5892,7 @@
             <a:endParaRPr lang="en-US" sz="1700" dirty="0"/>
           </a:p>
           <a:p>
-            <a:pPr indent="0" marL="0">
+            <a:pPr marL="0" indent="0">
               <a:spcAft>
                 <a:spcPts val="600"/>
               </a:spcAft>
@@ -6118,7 +5909,7 @@
             <a:endParaRPr lang="en-US" sz="1700" dirty="0"/>
           </a:p>
           <a:p>
-            <a:pPr indent="0" marL="0">
+            <a:pPr marL="0" indent="0">
               <a:spcAft>
                 <a:spcPts val="600"/>
               </a:spcAft>
@@ -6138,7 +5929,7 @@
       </p:sp>
       <p:sp>
         <p:nvSpPr>
-          <p:cNvPr id="25" name="Slide Number Placeholder 0"/>
+          <p:cNvPr id="37" name="Slide Number Placeholder 0"/>
           <p:cNvSpPr>
             <a:spLocks noGrp="1"/>
           </p:cNvSpPr>
@@ -6156,7 +5947,7 @@
           </a:prstGeom>
           <a:extLst>
             <a:ext uri="{C572A759-6A51-4108-AA02-DFA0A04FC94B}">
-              <ma14:wrappingTextBoxFlag xmlns:ma14="http://schemas.microsoft.com/office/mac/drawingml/2011/main" val="0"/>
+              <ma14:wrappingTextBoxFlag xmlns="" xmlns:ma14="http://schemas.microsoft.com/office/mac/drawingml/2011/main" val="0"/>
             </a:ext>
           </a:extLst>
         </p:spPr>
@@ -6174,7 +5965,7 @@
           <a:p>
             <a:pPr algn="r"/>
             <a:fld id="{F7021451-1387-4CA6-816F-3879F97B5CBC}" type="slidenum">
-              <a:rPr b="0" lang="en-US"/>
+              <a:rPr lang="en-US" b="0"/>
               <a:t>4</a:t>
             </a:fld>
             <a:endParaRPr lang="en-US"/>
@@ -6209,9 +6000,11 @@
       <p:sp>
         <p:nvSpPr>
           <p:cNvPr id="2" name="Text 0"/>
-          <p:cNvSpPr/>
+          <p:cNvSpPr>
+            <a:spLocks noGrp="1"/>
+          </p:cNvSpPr>
           <p:nvPr>
-            <p:ph idx="100" type="title" hasCustomPrompt="1"/>
+            <p:ph type="title" idx="100" hasCustomPrompt="1"/>
           </p:nvPr>
         </p:nvSpPr>
         <p:spPr>
@@ -6229,7 +6022,7 @@
           <a:bodyPr wrap="square" lIns="0" tIns="0" rIns="0" bIns="0" rtlCol="0" anchor="ctr"/>
           <a:lstStyle/>
           <a:p>
-            <a:pPr algn="l" indent="0" marL="0">
+            <a:pPr marL="0" indent="0" algn="l">
               <a:buNone/>
             </a:pPr>
             <a:r>
@@ -6274,14 +6067,14 @@
       </p:sp>
       <p:pic>
         <p:nvPicPr>
-          <p:cNvPr id="4" name="can-icon-0" descr="preencoded.png">    </p:cNvPr>
+          <p:cNvPr id="4" name="can-icon-0" descr="preencoded.png"/>
           <p:cNvPicPr>
             <a:picLocks noChangeAspect="1"/>
           </p:cNvPicPr>
           <p:nvPr/>
         </p:nvPicPr>
         <p:blipFill>
-          <a:blip r:embed="rId1"/>
+          <a:blip r:embed="rId3"/>
           <a:stretch>
             <a:fillRect/>
           </a:stretch>
@@ -6317,7 +6110,7 @@
           <a:bodyPr wrap="square" lIns="0" tIns="0" rIns="0" bIns="0" rtlCol="0" anchor="t"/>
           <a:lstStyle/>
           <a:p>
-            <a:pPr indent="0" marL="0">
+            <a:pPr marL="0" indent="0">
               <a:buNone/>
             </a:pPr>
             <a:r>
@@ -6353,7 +6146,7 @@
           <a:bodyPr wrap="square" lIns="0" tIns="0" rIns="0" bIns="0" rtlCol="0" anchor="t"/>
           <a:lstStyle/>
           <a:p>
-            <a:pPr indent="0" marL="0">
+            <a:pPr marL="0" indent="0">
               <a:buNone/>
             </a:pPr>
             <a:r>
@@ -6395,14 +6188,14 @@
       </p:sp>
       <p:pic>
         <p:nvPicPr>
-          <p:cNvPr id="8" name="can-icon-1" descr="preencoded.png">    </p:cNvPr>
+          <p:cNvPr id="8" name="can-icon-1" descr="preencoded.png"/>
           <p:cNvPicPr>
             <a:picLocks noChangeAspect="1"/>
           </p:cNvPicPr>
           <p:nvPr/>
         </p:nvPicPr>
         <p:blipFill>
-          <a:blip r:embed="rId2"/>
+          <a:blip r:embed="rId4"/>
           <a:stretch>
             <a:fillRect/>
           </a:stretch>
@@ -6438,7 +6231,7 @@
           <a:bodyPr wrap="square" lIns="0" tIns="0" rIns="0" bIns="0" rtlCol="0" anchor="t"/>
           <a:lstStyle/>
           <a:p>
-            <a:pPr indent="0" marL="0">
+            <a:pPr marL="0" indent="0">
               <a:buNone/>
             </a:pPr>
             <a:r>
@@ -6474,7 +6267,7 @@
           <a:bodyPr wrap="square" lIns="0" tIns="0" rIns="0" bIns="0" rtlCol="0" anchor="t"/>
           <a:lstStyle/>
           <a:p>
-            <a:pPr indent="0" marL="0">
+            <a:pPr marL="0" indent="0">
               <a:buNone/>
             </a:pPr>
             <a:r>
@@ -6516,14 +6309,14 @@
       </p:sp>
       <p:pic>
         <p:nvPicPr>
-          <p:cNvPr id="12" name="can-icon-2" descr="preencoded.png">    </p:cNvPr>
+          <p:cNvPr id="12" name="can-icon-2" descr="preencoded.png"/>
           <p:cNvPicPr>
             <a:picLocks noChangeAspect="1"/>
           </p:cNvPicPr>
           <p:nvPr/>
         </p:nvPicPr>
         <p:blipFill>
-          <a:blip r:embed="rId3"/>
+          <a:blip r:embed="rId5"/>
           <a:stretch>
             <a:fillRect/>
           </a:stretch>
@@ -6559,7 +6352,7 @@
           <a:bodyPr wrap="square" lIns="0" tIns="0" rIns="0" bIns="0" rtlCol="0" anchor="t"/>
           <a:lstStyle/>
           <a:p>
-            <a:pPr indent="0" marL="0">
+            <a:pPr marL="0" indent="0">
               <a:buNone/>
             </a:pPr>
             <a:r>
@@ -6595,7 +6388,7 @@
           <a:bodyPr wrap="square" lIns="0" tIns="0" rIns="0" bIns="0" rtlCol="0" anchor="t"/>
           <a:lstStyle/>
           <a:p>
-            <a:pPr indent="0" marL="0">
+            <a:pPr marL="0" indent="0">
               <a:buNone/>
             </a:pPr>
             <a:r>
@@ -6637,14 +6430,14 @@
       </p:sp>
       <p:pic>
         <p:nvPicPr>
-          <p:cNvPr id="16" name="can-icon-3" descr="preencoded.png">    </p:cNvPr>
+          <p:cNvPr id="16" name="can-icon-3" descr="preencoded.png"/>
           <p:cNvPicPr>
             <a:picLocks noChangeAspect="1"/>
           </p:cNvPicPr>
           <p:nvPr/>
         </p:nvPicPr>
         <p:blipFill>
-          <a:blip r:embed="rId4"/>
+          <a:blip r:embed="rId6"/>
           <a:stretch>
             <a:fillRect/>
           </a:stretch>
@@ -6680,7 +6473,7 @@
           <a:bodyPr wrap="square" lIns="0" tIns="0" rIns="0" bIns="0" rtlCol="0" anchor="t"/>
           <a:lstStyle/>
           <a:p>
-            <a:pPr indent="0" marL="0">
+            <a:pPr marL="0" indent="0">
               <a:buNone/>
             </a:pPr>
             <a:r>
@@ -6716,7 +6509,7 @@
           <a:bodyPr wrap="square" lIns="0" tIns="0" rIns="0" bIns="0" rtlCol="0" anchor="t"/>
           <a:lstStyle/>
           <a:p>
-            <a:pPr indent="0" marL="0">
+            <a:pPr marL="0" indent="0">
               <a:buNone/>
             </a:pPr>
             <a:r>
@@ -6779,7 +6572,7 @@
           <a:bodyPr wrap="square" lIns="0" tIns="0" rIns="0" bIns="0" rtlCol="0" anchor="t"/>
           <a:lstStyle/>
           <a:p>
-            <a:pPr indent="0" marL="0">
+            <a:pPr marL="0" indent="0">
               <a:buNone/>
             </a:pPr>
             <a:r>
@@ -6840,7 +6633,7 @@
           <a:bodyPr wrap="square" lIns="0" tIns="0" rIns="0" bIns="0" rtlCol="0" anchor="t"/>
           <a:lstStyle/>
           <a:p>
-            <a:pPr indent="0" marL="0">
+            <a:pPr marL="0" indent="0">
               <a:buNone/>
             </a:pPr>
             <a:r>
@@ -6876,7 +6669,7 @@
           <a:bodyPr wrap="square" lIns="0" tIns="0" rIns="0" bIns="0" rtlCol="0" anchor="t"/>
           <a:lstStyle/>
           <a:p>
-            <a:pPr indent="0" marL="0">
+            <a:pPr marL="0" indent="0">
               <a:buNone/>
             </a:pPr>
             <a:r>
@@ -6937,7 +6730,7 @@
           <a:bodyPr wrap="square" lIns="0" tIns="0" rIns="0" bIns="0" rtlCol="0" anchor="t"/>
           <a:lstStyle/>
           <a:p>
-            <a:pPr indent="0" marL="0">
+            <a:pPr marL="0" indent="0">
               <a:buNone/>
             </a:pPr>
             <a:r>
@@ -6973,7 +6766,7 @@
           <a:bodyPr wrap="square" lIns="0" tIns="0" rIns="0" bIns="0" rtlCol="0" anchor="t"/>
           <a:lstStyle/>
           <a:p>
-            <a:pPr indent="0" marL="0">
+            <a:pPr marL="0" indent="0">
               <a:buNone/>
             </a:pPr>
             <a:r>
@@ -7034,7 +6827,7 @@
           <a:bodyPr wrap="square" lIns="0" tIns="0" rIns="0" bIns="0" rtlCol="0" anchor="t"/>
           <a:lstStyle/>
           <a:p>
-            <a:pPr indent="0" marL="0">
+            <a:pPr marL="0" indent="0">
               <a:buNone/>
             </a:pPr>
             <a:r>
@@ -7070,7 +6863,7 @@
           <a:bodyPr wrap="square" lIns="0" tIns="0" rIns="0" bIns="0" rtlCol="0" anchor="t"/>
           <a:lstStyle/>
           <a:p>
-            <a:pPr indent="0" marL="0">
+            <a:pPr marL="0" indent="0">
               <a:buNone/>
             </a:pPr>
             <a:r>
@@ -7087,7 +6880,7 @@
       </p:sp>
       <p:sp>
         <p:nvSpPr>
-          <p:cNvPr id="25" name="Slide Number Placeholder 0"/>
+          <p:cNvPr id="30" name="Slide Number Placeholder 0"/>
           <p:cNvSpPr>
             <a:spLocks noGrp="1"/>
           </p:cNvSpPr>
@@ -7105,7 +6898,7 @@
           </a:prstGeom>
           <a:extLst>
             <a:ext uri="{C572A759-6A51-4108-AA02-DFA0A04FC94B}">
-              <ma14:wrappingTextBoxFlag xmlns:ma14="http://schemas.microsoft.com/office/mac/drawingml/2011/main" val="0"/>
+              <ma14:wrappingTextBoxFlag xmlns="" xmlns:ma14="http://schemas.microsoft.com/office/mac/drawingml/2011/main" val="0"/>
             </a:ext>
           </a:extLst>
         </p:spPr>
@@ -7123,7 +6916,7 @@
           <a:p>
             <a:pPr algn="r"/>
             <a:fld id="{F7021451-1387-4CA6-816F-3879F97B5CBC}" type="slidenum">
-              <a:rPr b="0" lang="en-US"/>
+              <a:rPr lang="en-US" b="0"/>
               <a:t>5</a:t>
             </a:fld>
             <a:endParaRPr lang="en-US"/>
@@ -7158,9 +6951,11 @@
       <p:sp>
         <p:nvSpPr>
           <p:cNvPr id="2" name="Text 0"/>
-          <p:cNvSpPr/>
+          <p:cNvSpPr>
+            <a:spLocks noGrp="1"/>
+          </p:cNvSpPr>
           <p:nvPr>
-            <p:ph idx="100" type="title" hasCustomPrompt="1"/>
+            <p:ph type="title" idx="100" hasCustomPrompt="1"/>
           </p:nvPr>
         </p:nvSpPr>
         <p:spPr>
@@ -7178,7 +6973,7 @@
           <a:bodyPr wrap="square" lIns="0" tIns="0" rIns="0" bIns="0" rtlCol="0" anchor="ctr"/>
           <a:lstStyle/>
           <a:p>
-            <a:pPr algn="l" indent="0" marL="0">
+            <a:pPr marL="0" indent="0" algn="l">
               <a:buNone/>
             </a:pPr>
             <a:r>
@@ -7244,7 +7039,7 @@
           <a:bodyPr wrap="square" lIns="0" tIns="0" rIns="0" bIns="0" rtlCol="0" anchor="t"/>
           <a:lstStyle/>
           <a:p>
-            <a:pPr indent="0" marL="0">
+            <a:pPr marL="0" indent="0">
               <a:buNone/>
             </a:pPr>
             <a:r>
@@ -7280,7 +7075,7 @@
           <a:bodyPr wrap="square" lIns="0" tIns="0" rIns="0" bIns="0" rtlCol="0" anchor="t"/>
           <a:lstStyle/>
           <a:p>
-            <a:pPr indent="0" marL="0">
+            <a:pPr marL="0" indent="0">
               <a:spcAft>
                 <a:spcPts val="800"/>
               </a:spcAft>
@@ -7300,7 +7095,7 @@
             <a:endParaRPr lang="en-US" sz="1500" dirty="0"/>
           </a:p>
           <a:p>
-            <a:pPr indent="0" marL="0">
+            <a:pPr marL="0" indent="0">
               <a:spcAft>
                 <a:spcPts val="800"/>
               </a:spcAft>
@@ -7320,7 +7115,7 @@
             <a:endParaRPr lang="en-US" sz="1500" dirty="0"/>
           </a:p>
           <a:p>
-            <a:pPr indent="0" marL="0">
+            <a:pPr marL="0" indent="0">
               <a:spcAft>
                 <a:spcPts val="800"/>
               </a:spcAft>
@@ -7340,7 +7135,7 @@
             <a:endParaRPr lang="en-US" sz="1500" dirty="0"/>
           </a:p>
           <a:p>
-            <a:pPr indent="0" marL="0">
+            <a:pPr marL="0" indent="0">
               <a:spcAft>
                 <a:spcPts val="800"/>
               </a:spcAft>
@@ -7360,7 +7155,7 @@
             <a:endParaRPr lang="en-US" sz="1500" dirty="0"/>
           </a:p>
           <a:p>
-            <a:pPr indent="0" marL="0">
+            <a:pPr marL="0" indent="0">
               <a:spcAft>
                 <a:spcPts val="800"/>
               </a:spcAft>
@@ -7402,7 +7197,7 @@
           <a:bodyPr wrap="square" lIns="0" tIns="0" rIns="0" bIns="0" rtlCol="0" anchor="t"/>
           <a:lstStyle/>
           <a:p>
-            <a:pPr indent="0" marL="0">
+            <a:pPr marL="0" indent="0">
               <a:buNone/>
             </a:pPr>
             <a:r>
@@ -7465,7 +7260,7 @@
           <a:bodyPr wrap="square" lIns="0" tIns="0" rIns="0" bIns="0" rtlCol="0" anchor="t"/>
           <a:lstStyle/>
           <a:p>
-            <a:pPr indent="0" marL="0">
+            <a:pPr marL="0" indent="0">
               <a:buNone/>
             </a:pPr>
             <a:r>
@@ -7501,7 +7296,7 @@
           <a:bodyPr wrap="square" lIns="0" tIns="0" rIns="0" bIns="0" rtlCol="0" anchor="t"/>
           <a:lstStyle/>
           <a:p>
-            <a:pPr indent="0" marL="0">
+            <a:pPr marL="0" indent="0">
               <a:buNone/>
             </a:pPr>
             <a:r>
@@ -7564,7 +7359,7 @@
           <a:bodyPr wrap="square" lIns="0" tIns="0" rIns="0" bIns="0" rtlCol="0" anchor="t"/>
           <a:lstStyle/>
           <a:p>
-            <a:pPr indent="0" marL="0">
+            <a:pPr marL="0" indent="0">
               <a:buNone/>
             </a:pPr>
             <a:r>
@@ -7600,7 +7395,7 @@
           <a:bodyPr wrap="square" lIns="0" tIns="0" rIns="0" bIns="0" rtlCol="0" anchor="t"/>
           <a:lstStyle/>
           <a:p>
-            <a:pPr indent="0" marL="0">
+            <a:pPr marL="0" indent="0">
               <a:buNone/>
             </a:pPr>
             <a:r>
@@ -7663,7 +7458,7 @@
           <a:bodyPr wrap="square" lIns="0" tIns="0" rIns="0" bIns="0" rtlCol="0" anchor="t"/>
           <a:lstStyle/>
           <a:p>
-            <a:pPr indent="0" marL="0">
+            <a:pPr marL="0" indent="0">
               <a:buNone/>
             </a:pPr>
             <a:r>
@@ -7699,7 +7494,7 @@
           <a:bodyPr wrap="square" lIns="0" tIns="0" rIns="0" bIns="0" rtlCol="0" anchor="t"/>
           <a:lstStyle/>
           <a:p>
-            <a:pPr indent="0" marL="0">
+            <a:pPr marL="0" indent="0">
               <a:buNone/>
             </a:pPr>
             <a:r>
@@ -7734,7 +7529,7 @@
           </a:prstGeom>
           <a:extLst>
             <a:ext uri="{C572A759-6A51-4108-AA02-DFA0A04FC94B}">
-              <ma14:wrappingTextBoxFlag xmlns:ma14="http://schemas.microsoft.com/office/mac/drawingml/2011/main" val="0"/>
+              <ma14:wrappingTextBoxFlag xmlns="" xmlns:ma14="http://schemas.microsoft.com/office/mac/drawingml/2011/main" val="0"/>
             </a:ext>
           </a:extLst>
         </p:spPr>
@@ -7752,7 +7547,7 @@
           <a:p>
             <a:pPr algn="r"/>
             <a:fld id="{F7021451-1387-4CA6-816F-3879F97B5CBC}" type="slidenum">
-              <a:rPr b="0" lang="en-US"/>
+              <a:rPr lang="en-US" b="0"/>
               <a:t>6</a:t>
             </a:fld>
             <a:endParaRPr lang="en-US"/>
@@ -7787,9 +7582,11 @@
       <p:sp>
         <p:nvSpPr>
           <p:cNvPr id="2" name="Text 0"/>
-          <p:cNvSpPr/>
+          <p:cNvSpPr>
+            <a:spLocks noGrp="1"/>
+          </p:cNvSpPr>
           <p:nvPr>
-            <p:ph idx="100" type="title" hasCustomPrompt="1"/>
+            <p:ph type="title" idx="100" hasCustomPrompt="1"/>
           </p:nvPr>
         </p:nvSpPr>
         <p:spPr>
@@ -7807,7 +7604,7 @@
           <a:bodyPr wrap="square" lIns="0" tIns="0" rIns="0" bIns="0" rtlCol="0" anchor="ctr"/>
           <a:lstStyle/>
           <a:p>
-            <a:pPr algn="l" indent="0" marL="0">
+            <a:pPr marL="0" indent="0" algn="l">
               <a:buNone/>
             </a:pPr>
             <a:r>
@@ -7827,17 +7624,23 @@
       </p:sp>
       <p:graphicFrame>
         <p:nvGraphicFramePr>
-          <p:cNvPr id="3" name="results-chart" descr=""/>
+          <p:cNvPr id="3" name="results-chart"/>
           <p:cNvGraphicFramePr/>
-          <p:nvPr/>
+          <p:nvPr>
+            <p:extLst>
+              <p:ext uri="{D42A27DB-BD31-4B8C-83A1-F6EECF244321}">
+                <p14:modId xmlns:p14="http://schemas.microsoft.com/office/powerpoint/2010/main" val="2427397473"/>
+              </p:ext>
+            </p:extLst>
+          </p:nvPr>
         </p:nvGraphicFramePr>
         <p:xfrm>
           <a:off x="548640" y="1280160"/>
           <a:ext cx="7040880" cy="4846320"/>
         </p:xfrm>
-        <a:graphic xmlns:a="http://schemas.openxmlformats.org/drawingml/2006/main">
+        <a:graphic>
           <a:graphicData uri="http://schemas.openxmlformats.org/drawingml/2006/chart">
-            <c:chart xmlns:c="http://schemas.openxmlformats.org/drawingml/2006/chart" r:id="rId1"/>
+            <c:chart xmlns:c="http://schemas.openxmlformats.org/drawingml/2006/chart" xmlns:r="http://schemas.openxmlformats.org/officeDocument/2006/relationships" r:id="rId3"/>
           </a:graphicData>
         </a:graphic>
       </p:graphicFrame>
@@ -7889,11 +7692,11 @@
           <a:bodyPr wrap="square" lIns="0" tIns="0" rIns="0" bIns="0" rtlCol="0" anchor="t"/>
           <a:lstStyle/>
           <a:p>
-            <a:pPr indent="0" marL="0">
-              <a:buNone/>
-            </a:pPr>
-            <a:r>
-              <a:rPr lang="en-US" sz="3600" b="1" dirty="0">
+            <a:pPr marL="0" indent="0">
+              <a:buNone/>
+            </a:pPr>
+            <a:r>
+              <a:rPr lang="en-US" sz="3600" b="1">
                 <a:solidFill>
                   <a:schemeClr val="accent1"/>
                 </a:solidFill>
@@ -7901,7 +7704,7 @@
                 <a:ea typeface="Cambria" pitchFamily="34" charset="-122"/>
                 <a:cs typeface="Cambria" pitchFamily="34" charset="-120"/>
               </a:rPr>
-              <a:t>573</a:t>
+              <a:t>608</a:t>
             </a:r>
             <a:endParaRPr lang="en-US" sz="3600" dirty="0"/>
           </a:p>
@@ -7928,7 +7731,7 @@
           <a:bodyPr wrap="square" lIns="0" tIns="0" rIns="0" bIns="0" rtlCol="0" anchor="t"/>
           <a:lstStyle/>
           <a:p>
-            <a:pPr indent="0" marL="0">
+            <a:pPr marL="0" indent="0">
               <a:buNone/>
             </a:pPr>
             <a:r>
@@ -7937,7 +7740,15 @@
                   <a:schemeClr val="tx1"/>
                 </a:solidFill>
               </a:rPr>
-              <a:t>kgCO2e/yr avoided by three sweep fixes</a:t>
+              <a:t>kgCO2e/</a:t>
+            </a:r>
+            <a:r>
+              <a:rPr lang="en-US" sz="1300">
+                <a:solidFill>
+                  <a:schemeClr val="tx1"/>
+                </a:solidFill>
+              </a:rPr>
+              <a:t>yr in four sweep fix PRs: proposed, not merged</a:t>
             </a:r>
             <a:endParaRPr lang="en-US" sz="1300" dirty="0"/>
           </a:p>
@@ -7991,7 +7802,7 @@
           <a:bodyPr wrap="square" lIns="0" tIns="0" rIns="0" bIns="0" rtlCol="0" anchor="t"/>
           <a:lstStyle/>
           <a:p>
-            <a:pPr indent="0" marL="0">
+            <a:pPr marL="0" indent="0">
               <a:buNone/>
             </a:pPr>
             <a:r>
@@ -8030,7 +7841,7 @@
           <a:bodyPr wrap="square" lIns="0" tIns="0" rIns="0" bIns="0" rtlCol="0" anchor="t"/>
           <a:lstStyle/>
           <a:p>
-            <a:pPr indent="0" marL="0">
+            <a:pPr marL="0" indent="0">
               <a:buNone/>
             </a:pPr>
             <a:r>
@@ -8039,7 +7850,31 @@
                   <a:schemeClr val="tx1"/>
                 </a:solidFill>
               </a:rPr>
-              <a:t>kgCO2e/yr stopped at review (range 263–1,104)</a:t>
+              <a:t>kgCO2e/</a:t>
+            </a:r>
+            <a:r>
+              <a:rPr lang="en-US" sz="1300">
+                <a:solidFill>
+                  <a:schemeClr val="tx1"/>
+                </a:solidFill>
+              </a:rPr>
+              <a:t>yr flagged at review </a:t>
+            </a:r>
+            <a:r>
+              <a:rPr lang="en-US" sz="1300" dirty="0">
+                <a:solidFill>
+                  <a:schemeClr val="tx1"/>
+                </a:solidFill>
+              </a:rPr>
+              <a:t>(</a:t>
+            </a:r>
+            <a:r>
+              <a:rPr lang="en-US" sz="1300">
+                <a:solidFill>
+                  <a:schemeClr val="tx1"/>
+                </a:solidFill>
+              </a:rPr>
+              <a:t>range 263–1,104, assumed load)</a:t>
             </a:r>
             <a:endParaRPr lang="en-US" sz="1300" dirty="0"/>
           </a:p>
@@ -8093,7 +7928,7 @@
           <a:bodyPr wrap="square" lIns="0" tIns="0" rIns="0" bIns="0" rtlCol="0" anchor="t"/>
           <a:lstStyle/>
           <a:p>
-            <a:pPr indent="0" marL="0">
+            <a:pPr marL="0" indent="0">
               <a:buNone/>
             </a:pPr>
             <a:r>
@@ -8132,7 +7967,7 @@
           <a:bodyPr wrap="square" lIns="0" tIns="0" rIns="0" bIns="0" rtlCol="0" anchor="t"/>
           <a:lstStyle/>
           <a:p>
-            <a:pPr indent="0" marL="0">
+            <a:pPr marL="0" indent="0">
               <a:buNone/>
             </a:pPr>
             <a:r>
@@ -8168,16 +8003,16 @@
           <a:bodyPr wrap="square" lIns="0" tIns="0" rIns="0" bIns="0" rtlCol="0" anchor="t"/>
           <a:lstStyle/>
           <a:p>
-            <a:pPr indent="0" marL="0">
-              <a:buNone/>
-            </a:pPr>
-            <a:r>
-              <a:rPr lang="en-US" sz="1100" dirty="0">
+            <a:pPr marL="0" indent="0">
+              <a:buNone/>
+            </a:pPr>
+            <a:r>
+              <a:rPr lang="en-US" sz="1100">
                 <a:solidFill>
                   <a:schemeClr val="accent5"/>
                 </a:solidFill>
               </a:rPr>
-              <a:t>Worked examples on the estate's own resources, reproduced by the test suite. Run metrics (precision, recall, trap violations, the agent's own energy) are in the README.</a:t>
+              <a:t>Seed 42 runs: precision 1.00, recall 0.80, 0 trap violations. The agent's own footprint: 0.26 g CO2e per run offline, 3.73 g with the local LLM (estimated).</a:t>
             </a:r>
             <a:endParaRPr lang="en-US" sz="1100" dirty="0"/>
           </a:p>
@@ -8203,7 +8038,7 @@
           </a:prstGeom>
           <a:extLst>
             <a:ext uri="{C572A759-6A51-4108-AA02-DFA0A04FC94B}">
-              <ma14:wrappingTextBoxFlag xmlns:ma14="http://schemas.microsoft.com/office/mac/drawingml/2011/main" val="0"/>
+              <ma14:wrappingTextBoxFlag xmlns="" xmlns:ma14="http://schemas.microsoft.com/office/mac/drawingml/2011/main" val="0"/>
             </a:ext>
           </a:extLst>
         </p:spPr>
@@ -8221,7 +8056,7 @@
           <a:p>
             <a:pPr algn="r"/>
             <a:fld id="{F7021451-1387-4CA6-816F-3879F97B5CBC}" type="slidenum">
-              <a:rPr b="0" lang="en-US"/>
+              <a:rPr lang="en-US" b="0"/>
               <a:t>7</a:t>
             </a:fld>
             <a:endParaRPr lang="en-US"/>
@@ -8256,9 +8091,11 @@
       <p:sp>
         <p:nvSpPr>
           <p:cNvPr id="2" name="Text 0"/>
-          <p:cNvSpPr/>
+          <p:cNvSpPr>
+            <a:spLocks noGrp="1"/>
+          </p:cNvSpPr>
           <p:nvPr>
-            <p:ph idx="100" type="title" hasCustomPrompt="1"/>
+            <p:ph type="title" idx="100" hasCustomPrompt="1"/>
           </p:nvPr>
         </p:nvSpPr>
         <p:spPr>
@@ -8276,7 +8113,7 @@
           <a:bodyPr wrap="square" lIns="0" tIns="0" rIns="0" bIns="0" rtlCol="0" anchor="ctr"/>
           <a:lstStyle/>
           <a:p>
-            <a:pPr algn="l" indent="0" marL="0">
+            <a:pPr marL="0" indent="0" algn="l">
               <a:buNone/>
             </a:pPr>
             <a:r>
@@ -8317,9 +8154,27 @@
             <a:tbl>
               <a:tblPr/>
               <a:tblGrid>
-                <a:gridCol w="1737360"/>
-                <a:gridCol w="2377440"/>
-                <a:gridCol w="3108960"/>
+                <a:gridCol w="1737360">
+                  <a:extLst>
+                    <a:ext uri="{9D8B030D-6E8A-4147-A177-3AD203B41FA5}">
+                      <a16:colId xmlns:a16="http://schemas.microsoft.com/office/drawing/2014/main" val="20000"/>
+                    </a:ext>
+                  </a:extLst>
+                </a:gridCol>
+                <a:gridCol w="2377440">
+                  <a:extLst>
+                    <a:ext uri="{9D8B030D-6E8A-4147-A177-3AD203B41FA5}">
+                      <a16:colId xmlns:a16="http://schemas.microsoft.com/office/drawing/2014/main" val="20001"/>
+                    </a:ext>
+                  </a:extLst>
+                </a:gridCol>
+                <a:gridCol w="3108960">
+                  <a:extLst>
+                    <a:ext uri="{9D8B030D-6E8A-4147-A177-3AD203B41FA5}">
+                      <a16:colId xmlns:a16="http://schemas.microsoft.com/office/drawing/2014/main" val="20002"/>
+                    </a:ext>
+                  </a:extLst>
+                </a:gridCol>
               </a:tblGrid>
               <a:tr h="566928">
                 <a:tc>
@@ -8327,7 +8182,7 @@
                     <a:bodyPr/>
                     <a:lstStyle/>
                     <a:p>
-                      <a:pPr indent="0" marL="0">
+                      <a:pPr marL="0" indent="0">
                         <a:buNone/>
                       </a:pPr>
                       <a:endParaRPr lang="en-US" sz="1200" dirty="0"/>
@@ -8380,7 +8235,7 @@
                     <a:bodyPr/>
                     <a:lstStyle/>
                     <a:p>
-                      <a:pPr indent="0" marL="0">
+                      <a:pPr marL="0" indent="0">
                         <a:buNone/>
                       </a:pPr>
                       <a:r>
@@ -8441,7 +8296,7 @@
                     <a:bodyPr/>
                     <a:lstStyle/>
                     <a:p>
-                      <a:pPr indent="0" marL="0">
+                      <a:pPr marL="0" indent="0">
                         <a:buNone/>
                       </a:pPr>
                       <a:r>
@@ -8497,6 +8352,11 @@
                     </a:solidFill>
                   </a:tcPr>
                 </a:tc>
+                <a:extLst>
+                  <a:ext uri="{0D108BD9-81ED-4DB2-BD59-A6C34878D82A}">
+                    <a16:rowId xmlns:a16="http://schemas.microsoft.com/office/drawing/2014/main" val="10000"/>
+                  </a:ext>
+                </a:extLst>
               </a:tr>
               <a:tr h="566928">
                 <a:tc>
@@ -8504,7 +8364,7 @@
                     <a:bodyPr/>
                     <a:lstStyle/>
                     <a:p>
-                      <a:pPr indent="0" marL="0">
+                      <a:pPr marL="0" indent="0">
                         <a:buNone/>
                       </a:pPr>
                       <a:r>
@@ -8565,7 +8425,7 @@
                     <a:bodyPr/>
                     <a:lstStyle/>
                     <a:p>
-                      <a:pPr indent="0" marL="0">
+                      <a:pPr marL="0" indent="0">
                         <a:buNone/>
                       </a:pPr>
                       <a:r>
@@ -8626,7 +8486,7 @@
                     <a:bodyPr/>
                     <a:lstStyle/>
                     <a:p>
-                      <a:pPr indent="0" marL="0">
+                      <a:pPr marL="0" indent="0">
                         <a:buNone/>
                       </a:pPr>
                       <a:r>
@@ -8682,6 +8542,11 @@
                     </a:solidFill>
                   </a:tcPr>
                 </a:tc>
+                <a:extLst>
+                  <a:ext uri="{0D108BD9-81ED-4DB2-BD59-A6C34878D82A}">
+                    <a16:rowId xmlns:a16="http://schemas.microsoft.com/office/drawing/2014/main" val="10001"/>
+                  </a:ext>
+                </a:extLst>
               </a:tr>
               <a:tr h="566928">
                 <a:tc>
@@ -8689,7 +8554,7 @@
                     <a:bodyPr/>
                     <a:lstStyle/>
                     <a:p>
-                      <a:pPr indent="0" marL="0">
+                      <a:pPr marL="0" indent="0">
                         <a:buNone/>
                       </a:pPr>
                       <a:r>
@@ -8750,7 +8615,7 @@
                     <a:bodyPr/>
                     <a:lstStyle/>
                     <a:p>
-                      <a:pPr indent="0" marL="0">
+                      <a:pPr marL="0" indent="0">
                         <a:buNone/>
                       </a:pPr>
                       <a:r>
@@ -8811,7 +8676,7 @@
                     <a:bodyPr/>
                     <a:lstStyle/>
                     <a:p>
-                      <a:pPr indent="0" marL="0">
+                      <a:pPr marL="0" indent="0">
                         <a:buNone/>
                       </a:pPr>
                       <a:r>
@@ -8867,6 +8732,11 @@
                     </a:solidFill>
                   </a:tcPr>
                 </a:tc>
+                <a:extLst>
+                  <a:ext uri="{0D108BD9-81ED-4DB2-BD59-A6C34878D82A}">
+                    <a16:rowId xmlns:a16="http://schemas.microsoft.com/office/drawing/2014/main" val="10002"/>
+                  </a:ext>
+                </a:extLst>
               </a:tr>
               <a:tr h="566928">
                 <a:tc>
@@ -8874,7 +8744,7 @@
                     <a:bodyPr/>
                     <a:lstStyle/>
                     <a:p>
-                      <a:pPr indent="0" marL="0">
+                      <a:pPr marL="0" indent="0">
                         <a:buNone/>
                       </a:pPr>
                       <a:r>
@@ -8935,7 +8805,7 @@
                     <a:bodyPr/>
                     <a:lstStyle/>
                     <a:p>
-                      <a:pPr indent="0" marL="0">
+                      <a:pPr marL="0" indent="0">
                         <a:buNone/>
                       </a:pPr>
                       <a:r>
@@ -8996,7 +8866,7 @@
                     <a:bodyPr/>
                     <a:lstStyle/>
                     <a:p>
-                      <a:pPr indent="0" marL="0">
+                      <a:pPr marL="0" indent="0">
                         <a:buNone/>
                       </a:pPr>
                       <a:r>
@@ -9052,6 +8922,11 @@
                     </a:solidFill>
                   </a:tcPr>
                 </a:tc>
+                <a:extLst>
+                  <a:ext uri="{0D108BD9-81ED-4DB2-BD59-A6C34878D82A}">
+                    <a16:rowId xmlns:a16="http://schemas.microsoft.com/office/drawing/2014/main" val="10003"/>
+                  </a:ext>
+                </a:extLst>
               </a:tr>
               <a:tr h="566928">
                 <a:tc>
@@ -9059,7 +8934,7 @@
                     <a:bodyPr/>
                     <a:lstStyle/>
                     <a:p>
-                      <a:pPr indent="0" marL="0">
+                      <a:pPr marL="0" indent="0">
                         <a:buNone/>
                       </a:pPr>
                       <a:r>
@@ -9120,7 +8995,7 @@
                     <a:bodyPr/>
                     <a:lstStyle/>
                     <a:p>
-                      <a:pPr indent="0" marL="0">
+                      <a:pPr marL="0" indent="0">
                         <a:buNone/>
                       </a:pPr>
                       <a:r>
@@ -9181,7 +9056,7 @@
                     <a:bodyPr/>
                     <a:lstStyle/>
                     <a:p>
-                      <a:pPr indent="0" marL="0">
+                      <a:pPr marL="0" indent="0">
                         <a:buNone/>
                       </a:pPr>
                       <a:r>
@@ -9237,6 +9112,11 @@
                     </a:solidFill>
                   </a:tcPr>
                 </a:tc>
+                <a:extLst>
+                  <a:ext uri="{0D108BD9-81ED-4DB2-BD59-A6C34878D82A}">
+                    <a16:rowId xmlns:a16="http://schemas.microsoft.com/office/drawing/2014/main" val="10004"/>
+                  </a:ext>
+                </a:extLst>
               </a:tr>
               <a:tr h="566928">
                 <a:tc>
@@ -9244,7 +9124,7 @@
                     <a:bodyPr/>
                     <a:lstStyle/>
                     <a:p>
-                      <a:pPr indent="0" marL="0">
+                      <a:pPr marL="0" indent="0">
                         <a:buNone/>
                       </a:pPr>
                       <a:r>
@@ -9305,7 +9185,7 @@
                     <a:bodyPr/>
                     <a:lstStyle/>
                     <a:p>
-                      <a:pPr indent="0" marL="0">
+                      <a:pPr marL="0" indent="0">
                         <a:buNone/>
                       </a:pPr>
                       <a:r>
@@ -9366,7 +9246,7 @@
                     <a:bodyPr/>
                     <a:lstStyle/>
                     <a:p>
-                      <a:pPr indent="0" marL="0">
+                      <a:pPr marL="0" indent="0">
                         <a:buNone/>
                       </a:pPr>
                       <a:r>
@@ -9422,6 +9302,11 @@
                     </a:solidFill>
                   </a:tcPr>
                 </a:tc>
+                <a:extLst>
+                  <a:ext uri="{0D108BD9-81ED-4DB2-BD59-A6C34878D82A}">
+                    <a16:rowId xmlns:a16="http://schemas.microsoft.com/office/drawing/2014/main" val="10005"/>
+                  </a:ext>
+                </a:extLst>
               </a:tr>
             </a:tbl>
           </a:graphicData>
@@ -9456,14 +9341,14 @@
       </p:sp>
       <p:pic>
         <p:nvPicPr>
-          <p:cNvPr id="5" name="impact-icon" descr="preencoded.png">    </p:cNvPr>
+          <p:cNvPr id="5" name="impact-icon" descr="preencoded.png"/>
           <p:cNvPicPr>
             <a:picLocks noChangeAspect="1"/>
           </p:cNvPicPr>
           <p:nvPr/>
         </p:nvPicPr>
         <p:blipFill>
-          <a:blip r:embed="rId1"/>
+          <a:blip r:embed="rId3"/>
           <a:stretch>
             <a:fillRect/>
           </a:stretch>
@@ -9499,7 +9384,7 @@
           <a:bodyPr wrap="square" lIns="0" tIns="0" rIns="0" bIns="0" rtlCol="0" anchor="t"/>
           <a:lstStyle/>
           <a:p>
-            <a:pPr indent="0" marL="0">
+            <a:pPr marL="0" indent="0">
               <a:buNone/>
             </a:pPr>
             <a:r>
@@ -9513,7 +9398,7 @@
             <a:endParaRPr lang="en-US" sz="2000" dirty="0"/>
           </a:p>
           <a:p>
-            <a:pPr indent="0" marL="0">
+            <a:pPr marL="0" indent="0">
               <a:buNone/>
             </a:pPr>
             <a:r>
@@ -9527,7 +9412,7 @@
             <a:endParaRPr lang="en-US" sz="2000" dirty="0"/>
           </a:p>
           <a:p>
-            <a:pPr indent="0" marL="0">
+            <a:pPr marL="0" indent="0">
               <a:buNone/>
             </a:pPr>
             <a:r>
@@ -9562,7 +9447,7 @@
           </a:prstGeom>
           <a:extLst>
             <a:ext uri="{C572A759-6A51-4108-AA02-DFA0A04FC94B}">
-              <ma14:wrappingTextBoxFlag xmlns:ma14="http://schemas.microsoft.com/office/mac/drawingml/2011/main" val="0"/>
+              <ma14:wrappingTextBoxFlag xmlns="" xmlns:ma14="http://schemas.microsoft.com/office/mac/drawingml/2011/main" val="0"/>
             </a:ext>
           </a:extLst>
         </p:spPr>
@@ -9580,7 +9465,7 @@
           <a:p>
             <a:pPr algn="r"/>
             <a:fld id="{F7021451-1387-4CA6-816F-3879F97B5CBC}" type="slidenum">
-              <a:rPr b="0" lang="en-US"/>
+              <a:rPr lang="en-US" b="0"/>
               <a:t>8</a:t>
             </a:fld>
             <a:endParaRPr lang="en-US"/>
@@ -9615,9 +9500,11 @@
       <p:sp>
         <p:nvSpPr>
           <p:cNvPr id="2" name="Text 0"/>
-          <p:cNvSpPr/>
+          <p:cNvSpPr>
+            <a:spLocks noGrp="1"/>
+          </p:cNvSpPr>
           <p:nvPr>
-            <p:ph idx="100" type="title" hasCustomPrompt="1"/>
+            <p:ph type="title" idx="100" hasCustomPrompt="1"/>
           </p:nvPr>
         </p:nvSpPr>
         <p:spPr>
@@ -9635,7 +9522,7 @@
           <a:bodyPr wrap="square" lIns="0" tIns="0" rIns="0" bIns="0" rtlCol="0" anchor="ctr"/>
           <a:lstStyle/>
           <a:p>
-            <a:pPr algn="l" indent="0" marL="0">
+            <a:pPr marL="0" indent="0" algn="l">
               <a:buNone/>
             </a:pPr>
             <a:r>
@@ -9707,14 +9594,14 @@
       </p:sp>
       <p:pic>
         <p:nvPicPr>
-          <p:cNvPr id="5" name="eff-icon-0" descr="preencoded.png">    </p:cNvPr>
+          <p:cNvPr id="5" name="eff-icon-0" descr="preencoded.png"/>
           <p:cNvPicPr>
             <a:picLocks noChangeAspect="1"/>
           </p:cNvPicPr>
           <p:nvPr/>
         </p:nvPicPr>
         <p:blipFill>
-          <a:blip r:embed="rId1"/>
+          <a:blip r:embed="rId3"/>
           <a:stretch>
             <a:fillRect/>
           </a:stretch>
@@ -9750,7 +9637,7 @@
           <a:bodyPr wrap="square" lIns="0" tIns="0" rIns="0" bIns="0" rtlCol="0" anchor="ctr"/>
           <a:lstStyle/>
           <a:p>
-            <a:pPr indent="0" marL="0">
+            <a:pPr marL="0" indent="0">
               <a:buNone/>
             </a:pPr>
             <a:r>
@@ -9786,7 +9673,7 @@
           <a:bodyPr wrap="square" lIns="0" tIns="0" rIns="0" bIns="0" rtlCol="0" anchor="t"/>
           <a:lstStyle/>
           <a:p>
-            <a:pPr indent="0" marL="0">
+            <a:pPr marL="0" indent="0">
               <a:buNone/>
             </a:pPr>
             <a:r>
@@ -9855,14 +9742,14 @@
       </p:sp>
       <p:pic>
         <p:nvPicPr>
-          <p:cNvPr id="10" name="eff-icon-1" descr="preencoded.png">    </p:cNvPr>
+          <p:cNvPr id="10" name="eff-icon-1" descr="preencoded.png"/>
           <p:cNvPicPr>
             <a:picLocks noChangeAspect="1"/>
           </p:cNvPicPr>
           <p:nvPr/>
         </p:nvPicPr>
         <p:blipFill>
-          <a:blip r:embed="rId2"/>
+          <a:blip r:embed="rId4"/>
           <a:stretch>
             <a:fillRect/>
           </a:stretch>
@@ -9898,7 +9785,7 @@
           <a:bodyPr wrap="square" lIns="0" tIns="0" rIns="0" bIns="0" rtlCol="0" anchor="ctr"/>
           <a:lstStyle/>
           <a:p>
-            <a:pPr indent="0" marL="0">
+            <a:pPr marL="0" indent="0">
               <a:buNone/>
             </a:pPr>
             <a:r>
@@ -9934,7 +9821,7 @@
           <a:bodyPr wrap="square" lIns="0" tIns="0" rIns="0" bIns="0" rtlCol="0" anchor="t"/>
           <a:lstStyle/>
           <a:p>
-            <a:pPr indent="0" marL="0">
+            <a:pPr marL="0" indent="0">
               <a:buNone/>
             </a:pPr>
             <a:r>
@@ -9943,7 +9830,15 @@
                   <a:schemeClr val="tx1"/>
                 </a:solidFill>
               </a:rPr>
-              <a:t>gpt-oss-20b (Apache-2.0), ~3.6B active parameters, low reasoning by default</a:t>
+              <a:t>gpt-oss-20b (Apache-2.0), ~3.6B active parameters</a:t>
+            </a:r>
+            <a:r>
+              <a:rPr lang="en-US" sz="1300">
+                <a:solidFill>
+                  <a:schemeClr val="tx1"/>
+                </a:solidFill>
+              </a:rPr>
+              <a:t>, low reasoning for prose, medium for decisions</a:t>
             </a:r>
             <a:endParaRPr lang="en-US" sz="1300" dirty="0"/>
           </a:p>
@@ -10003,14 +9898,14 @@
       </p:sp>
       <p:pic>
         <p:nvPicPr>
-          <p:cNvPr id="15" name="eff-icon-2" descr="preencoded.png">    </p:cNvPr>
+          <p:cNvPr id="15" name="eff-icon-2" descr="preencoded.png"/>
           <p:cNvPicPr>
             <a:picLocks noChangeAspect="1"/>
           </p:cNvPicPr>
           <p:nvPr/>
         </p:nvPicPr>
         <p:blipFill>
-          <a:blip r:embed="rId3"/>
+          <a:blip r:embed="rId5"/>
           <a:stretch>
             <a:fillRect/>
           </a:stretch>
@@ -10046,7 +9941,7 @@
           <a:bodyPr wrap="square" lIns="0" tIns="0" rIns="0" bIns="0" rtlCol="0" anchor="ctr"/>
           <a:lstStyle/>
           <a:p>
-            <a:pPr indent="0" marL="0">
+            <a:pPr marL="0" indent="0">
               <a:buNone/>
             </a:pPr>
             <a:r>
@@ -10082,7 +9977,7 @@
           <a:bodyPr wrap="square" lIns="0" tIns="0" rIns="0" bIns="0" rtlCol="0" anchor="t"/>
           <a:lstStyle/>
           <a:p>
-            <a:pPr indent="0" marL="0">
+            <a:pPr marL="0" indent="0">
               <a:buNone/>
             </a:pPr>
             <a:r>
@@ -10151,14 +10046,14 @@
       </p:sp>
       <p:pic>
         <p:nvPicPr>
-          <p:cNvPr id="20" name="eff-icon-3" descr="preencoded.png">    </p:cNvPr>
+          <p:cNvPr id="20" name="eff-icon-3" descr="preencoded.png"/>
           <p:cNvPicPr>
             <a:picLocks noChangeAspect="1"/>
           </p:cNvPicPr>
           <p:nvPr/>
         </p:nvPicPr>
         <p:blipFill>
-          <a:blip r:embed="rId4"/>
+          <a:blip r:embed="rId6"/>
           <a:stretch>
             <a:fillRect/>
           </a:stretch>
@@ -10194,7 +10089,7 @@
           <a:bodyPr wrap="square" lIns="0" tIns="0" rIns="0" bIns="0" rtlCol="0" anchor="ctr"/>
           <a:lstStyle/>
           <a:p>
-            <a:pPr indent="0" marL="0">
+            <a:pPr marL="0" indent="0">
               <a:buNone/>
             </a:pPr>
             <a:r>
@@ -10230,7 +10125,7 @@
           <a:bodyPr wrap="square" lIns="0" tIns="0" rIns="0" bIns="0" rtlCol="0" anchor="t"/>
           <a:lstStyle/>
           <a:p>
-            <a:pPr indent="0" marL="0">
+            <a:pPr marL="0" indent="0">
               <a:buNone/>
             </a:pPr>
             <a:r>
@@ -10299,14 +10194,14 @@
       </p:sp>
       <p:pic>
         <p:nvPicPr>
-          <p:cNvPr id="25" name="eff-icon-4" descr="preencoded.png">    </p:cNvPr>
+          <p:cNvPr id="25" name="eff-icon-4" descr="preencoded.png"/>
           <p:cNvPicPr>
             <a:picLocks noChangeAspect="1"/>
           </p:cNvPicPr>
           <p:nvPr/>
         </p:nvPicPr>
         <p:blipFill>
-          <a:blip r:embed="rId5"/>
+          <a:blip r:embed="rId7"/>
           <a:stretch>
             <a:fillRect/>
           </a:stretch>
@@ -10342,7 +10237,7 @@
           <a:bodyPr wrap="square" lIns="0" tIns="0" rIns="0" bIns="0" rtlCol="0" anchor="ctr"/>
           <a:lstStyle/>
           <a:p>
-            <a:pPr indent="0" marL="0">
+            <a:pPr marL="0" indent="0">
               <a:buNone/>
             </a:pPr>
             <a:r>
@@ -10378,7 +10273,7 @@
           <a:bodyPr wrap="square" lIns="0" tIns="0" rIns="0" bIns="0" rtlCol="0" anchor="t"/>
           <a:lstStyle/>
           <a:p>
-            <a:pPr indent="0" marL="0">
+            <a:pPr marL="0" indent="0">
               <a:buNone/>
             </a:pPr>
             <a:r>
@@ -10447,14 +10342,14 @@
       </p:sp>
       <p:pic>
         <p:nvPicPr>
-          <p:cNvPr id="30" name="eff-icon-5" descr="preencoded.png">    </p:cNvPr>
+          <p:cNvPr id="30" name="eff-icon-5" descr="preencoded.png"/>
           <p:cNvPicPr>
             <a:picLocks noChangeAspect="1"/>
           </p:cNvPicPr>
           <p:nvPr/>
         </p:nvPicPr>
         <p:blipFill>
-          <a:blip r:embed="rId6"/>
+          <a:blip r:embed="rId8"/>
           <a:stretch>
             <a:fillRect/>
           </a:stretch>
@@ -10490,7 +10385,7 @@
           <a:bodyPr wrap="square" lIns="0" tIns="0" rIns="0" bIns="0" rtlCol="0" anchor="ctr"/>
           <a:lstStyle/>
           <a:p>
-            <a:pPr indent="0" marL="0">
+            <a:pPr marL="0" indent="0">
               <a:buNone/>
             </a:pPr>
             <a:r>
@@ -10526,7 +10421,7 @@
           <a:bodyPr wrap="square" lIns="0" tIns="0" rIns="0" bIns="0" rtlCol="0" anchor="t"/>
           <a:lstStyle/>
           <a:p>
-            <a:pPr indent="0" marL="0">
+            <a:pPr marL="0" indent="0">
               <a:buNone/>
             </a:pPr>
             <a:r>
@@ -10589,7 +10484,7 @@
           <a:bodyPr wrap="square" lIns="0" tIns="0" rIns="0" bIns="0" rtlCol="0" anchor="ctr"/>
           <a:lstStyle/>
           <a:p>
-            <a:pPr indent="0" marL="0">
+            <a:pPr marL="0" indent="0">
               <a:buNone/>
             </a:pPr>
             <a:r>
@@ -10600,16 +10495,21 @@
               </a:rPr>
               <a:t>Own footprint, every run:  </a:t>
             </a:r>
-            <a:pPr indent="0" marL="0">
-              <a:buNone/>
-            </a:pPr>
             <a:r>
               <a:rPr lang="en-US" sz="1400" dirty="0">
                 <a:solidFill>
                   <a:schemeClr val="accent6"/>
                 </a:solidFill>
               </a:rPr>
-              <a:t>CodeCarbon wraps the whole run, model included → kWh, kgCO2e per run (SCI, ISO/IEC 21031), tokens, and payback ratio = kgCO2e/yr proposed ÷ kgCO2e emitted. Labelled 'estimated' where the laptop has no power counters.</a:t>
+              <a:t>CodeCarbon wraps the whole run, model included → kWh, kgCO2e per run (SCI, ISO/IEC 21031), tokens, and payback ratio = kgCO2e/yr proposed ÷ kgCO2e emitted. Labelled </a:t>
+            </a:r>
+            <a:r>
+              <a:rPr lang="en-US" sz="1400">
+                <a:solidFill>
+                  <a:schemeClr val="accent6"/>
+                </a:solidFill>
+              </a:rPr>
+              <a:t>'estimated': CPU energy from hardware counters, RAM modelled.</a:t>
             </a:r>
             <a:endParaRPr lang="en-US" sz="1400" dirty="0"/>
           </a:p>
@@ -10617,7 +10517,7 @@
       </p:sp>
       <p:sp>
         <p:nvSpPr>
-          <p:cNvPr id="25" name="Slide Number Placeholder 0"/>
+          <p:cNvPr id="35" name="Slide Number Placeholder 0"/>
           <p:cNvSpPr>
             <a:spLocks noGrp="1"/>
           </p:cNvSpPr>
@@ -10635,7 +10535,7 @@
           </a:prstGeom>
           <a:extLst>
             <a:ext uri="{C572A759-6A51-4108-AA02-DFA0A04FC94B}">
-              <ma14:wrappingTextBoxFlag xmlns:ma14="http://schemas.microsoft.com/office/mac/drawingml/2011/main" val="0"/>
+              <ma14:wrappingTextBoxFlag xmlns="" xmlns:ma14="http://schemas.microsoft.com/office/mac/drawingml/2011/main" val="0"/>
             </a:ext>
           </a:extLst>
         </p:spPr>
@@ -10653,7 +10553,7 @@
           <a:p>
             <a:pPr algn="r"/>
             <a:fld id="{F7021451-1387-4CA6-816F-3879F97B5CBC}" type="slidenum">
-              <a:rPr b="0" lang="en-US"/>
+              <a:rPr lang="en-US" b="0"/>
               <a:t>9</a:t>
             </a:fld>
             <a:endParaRPr lang="en-US"/>
@@ -10961,4 +10861,319 @@
     </a:ext>
   </a:extLst>
 </a:theme>
+</file>
+
+<file path=ppt/theme/theme2.xml><?xml version="1.0" encoding="utf-8"?>
+<a:theme xmlns:a="http://schemas.openxmlformats.org/drawingml/2006/main" name="Office Theme">
+  <a:themeElements>
+    <a:clrScheme name="Office">
+      <a:dk1>
+        <a:sysClr val="windowText" lastClr="000000"/>
+      </a:dk1>
+      <a:lt1>
+        <a:sysClr val="window" lastClr="FFFFFF"/>
+      </a:lt1>
+      <a:dk2>
+        <a:srgbClr val="0E2841"/>
+      </a:dk2>
+      <a:lt2>
+        <a:srgbClr val="E8E8E8"/>
+      </a:lt2>
+      <a:accent1>
+        <a:srgbClr val="156082"/>
+      </a:accent1>
+      <a:accent2>
+        <a:srgbClr val="E97132"/>
+      </a:accent2>
+      <a:accent3>
+        <a:srgbClr val="196B24"/>
+      </a:accent3>
+      <a:accent4>
+        <a:srgbClr val="0F9ED5"/>
+      </a:accent4>
+      <a:accent5>
+        <a:srgbClr val="A02B93"/>
+      </a:accent5>
+      <a:accent6>
+        <a:srgbClr val="4EA72E"/>
+      </a:accent6>
+      <a:hlink>
+        <a:srgbClr val="467886"/>
+      </a:hlink>
+      <a:folHlink>
+        <a:srgbClr val="96607D"/>
+      </a:folHlink>
+    </a:clrScheme>
+    <a:fontScheme name="Office">
+      <a:majorFont>
+        <a:latin typeface="Aptos Display" panose="02110004020202020204"/>
+        <a:ea typeface=""/>
+        <a:cs typeface=""/>
+        <a:font script="Jpan" typeface="游ゴシック Light"/>
+        <a:font script="Hang" typeface="맑은 고딕"/>
+        <a:font script="Hans" typeface="等线 Light"/>
+        <a:font script="Hant" typeface="新細明體"/>
+        <a:font script="Arab" typeface="Times New Roman"/>
+        <a:font script="Hebr" typeface="Times New Roman"/>
+        <a:font script="Thai" typeface="Angsana New"/>
+        <a:font script="Ethi" typeface="Nyala"/>
+        <a:font script="Beng" typeface="Vrinda"/>
+        <a:font script="Gujr" typeface="Shruti"/>
+        <a:font script="Khmr" typeface="MoolBoran"/>
+        <a:font script="Knda" typeface="Tunga"/>
+        <a:font script="Guru" typeface="Raavi"/>
+        <a:font script="Cans" typeface="Euphemia"/>
+        <a:font script="Cher" typeface="Plantagenet Cherokee"/>
+        <a:font script="Yiii" typeface="Microsoft Yi Baiti"/>
+        <a:font script="Tibt" typeface="Microsoft Himalaya"/>
+        <a:font script="Thaa" typeface="MV Boli"/>
+        <a:font script="Deva" typeface="Mangal"/>
+        <a:font script="Telu" typeface="Gautami"/>
+        <a:font script="Taml" typeface="Latha"/>
+        <a:font script="Syrc" typeface="Estrangelo Edessa"/>
+        <a:font script="Orya" typeface="Kalinga"/>
+        <a:font script="Mlym" typeface="Kartika"/>
+        <a:font script="Laoo" typeface="DokChampa"/>
+        <a:font script="Sinh" typeface="Iskoola Pota"/>
+        <a:font script="Mong" typeface="Mongolian Baiti"/>
+        <a:font script="Viet" typeface="Times New Roman"/>
+        <a:font script="Uigh" typeface="Microsoft Uighur"/>
+        <a:font script="Geor" typeface="Sylfaen"/>
+        <a:font script="Armn" typeface="Arial"/>
+        <a:font script="Bugi" typeface="Leelawadee UI"/>
+        <a:font script="Bopo" typeface="Microsoft JhengHei"/>
+        <a:font script="Java" typeface="Javanese Text"/>
+        <a:font script="Lisu" typeface="Segoe UI"/>
+        <a:font script="Mymr" typeface="Myanmar Text"/>
+        <a:font script="Nkoo" typeface="Ebrima"/>
+        <a:font script="Olck" typeface="Nirmala UI"/>
+        <a:font script="Osma" typeface="Ebrima"/>
+        <a:font script="Phag" typeface="Phagspa"/>
+        <a:font script="Syrn" typeface="Estrangelo Edessa"/>
+        <a:font script="Syrj" typeface="Estrangelo Edessa"/>
+        <a:font script="Syre" typeface="Estrangelo Edessa"/>
+        <a:font script="Sora" typeface="Nirmala UI"/>
+        <a:font script="Tale" typeface="Microsoft Tai Le"/>
+        <a:font script="Talu" typeface="Microsoft New Tai Lue"/>
+        <a:font script="Tfng" typeface="Ebrima"/>
+      </a:majorFont>
+      <a:minorFont>
+        <a:latin typeface="Aptos" panose="02110004020202020204"/>
+        <a:ea typeface=""/>
+        <a:cs typeface=""/>
+        <a:font script="Jpan" typeface="游ゴシック"/>
+        <a:font script="Hang" typeface="맑은 고딕"/>
+        <a:font script="Hans" typeface="等线"/>
+        <a:font script="Hant" typeface="新細明體"/>
+        <a:font script="Arab" typeface="Arial"/>
+        <a:font script="Hebr" typeface="Arial"/>
+        <a:font script="Thai" typeface="Cordia New"/>
+        <a:font script="Ethi" typeface="Nyala"/>
+        <a:font script="Beng" typeface="Vrinda"/>
+        <a:font script="Gujr" typeface="Shruti"/>
+        <a:font script="Khmr" typeface="DaunPenh"/>
+        <a:font script="Knda" typeface="Tunga"/>
+        <a:font script="Guru" typeface="Raavi"/>
+        <a:font script="Cans" typeface="Euphemia"/>
+        <a:font script="Cher" typeface="Plantagenet Cherokee"/>
+        <a:font script="Yiii" typeface="Microsoft Yi Baiti"/>
+        <a:font script="Tibt" typeface="Microsoft Himalaya"/>
+        <a:font script="Thaa" typeface="MV Boli"/>
+        <a:font script="Deva" typeface="Mangal"/>
+        <a:font script="Telu" typeface="Gautami"/>
+        <a:font script="Taml" typeface="Latha"/>
+        <a:font script="Syrc" typeface="Estrangelo Edessa"/>
+        <a:font script="Orya" typeface="Kalinga"/>
+        <a:font script="Mlym" typeface="Kartika"/>
+        <a:font script="Laoo" typeface="DokChampa"/>
+        <a:font script="Sinh" typeface="Iskoola Pota"/>
+        <a:font script="Mong" typeface="Mongolian Baiti"/>
+        <a:font script="Viet" typeface="Arial"/>
+        <a:font script="Uigh" typeface="Microsoft Uighur"/>
+        <a:font script="Geor" typeface="Sylfaen"/>
+        <a:font script="Armn" typeface="Arial"/>
+        <a:font script="Bugi" typeface="Leelawadee UI"/>
+        <a:font script="Bopo" typeface="Microsoft JhengHei"/>
+        <a:font script="Java" typeface="Javanese Text"/>
+        <a:font script="Lisu" typeface="Segoe UI"/>
+        <a:font script="Mymr" typeface="Myanmar Text"/>
+        <a:font script="Nkoo" typeface="Ebrima"/>
+        <a:font script="Olck" typeface="Nirmala UI"/>
+        <a:font script="Osma" typeface="Ebrima"/>
+        <a:font script="Phag" typeface="Phagspa"/>
+        <a:font script="Syrn" typeface="Estrangelo Edessa"/>
+        <a:font script="Syrj" typeface="Estrangelo Edessa"/>
+        <a:font script="Syre" typeface="Estrangelo Edessa"/>
+        <a:font script="Sora" typeface="Nirmala UI"/>
+        <a:font script="Tale" typeface="Microsoft Tai Le"/>
+        <a:font script="Talu" typeface="Microsoft New Tai Lue"/>
+        <a:font script="Tfng" typeface="Ebrima"/>
+      </a:minorFont>
+    </a:fontScheme>
+    <a:fmtScheme name="Office">
+      <a:fillStyleLst>
+        <a:solidFill>
+          <a:schemeClr val="phClr"/>
+        </a:solidFill>
+        <a:gradFill rotWithShape="1">
+          <a:gsLst>
+            <a:gs pos="0">
+              <a:schemeClr val="phClr">
+                <a:lumMod val="110000"/>
+                <a:satMod val="105000"/>
+                <a:tint val="67000"/>
+              </a:schemeClr>
+            </a:gs>
+            <a:gs pos="50000">
+              <a:schemeClr val="phClr">
+                <a:lumMod val="105000"/>
+                <a:satMod val="103000"/>
+                <a:tint val="73000"/>
+              </a:schemeClr>
+            </a:gs>
+            <a:gs pos="100000">
+              <a:schemeClr val="phClr">
+                <a:lumMod val="105000"/>
+                <a:satMod val="109000"/>
+                <a:tint val="81000"/>
+              </a:schemeClr>
+            </a:gs>
+          </a:gsLst>
+          <a:lin ang="5400000" scaled="0"/>
+        </a:gradFill>
+        <a:gradFill rotWithShape="1">
+          <a:gsLst>
+            <a:gs pos="0">
+              <a:schemeClr val="phClr">
+                <a:satMod val="103000"/>
+                <a:lumMod val="102000"/>
+                <a:tint val="94000"/>
+              </a:schemeClr>
+            </a:gs>
+            <a:gs pos="50000">
+              <a:schemeClr val="phClr">
+                <a:satMod val="110000"/>
+                <a:lumMod val="100000"/>
+                <a:shade val="100000"/>
+              </a:schemeClr>
+            </a:gs>
+            <a:gs pos="100000">
+              <a:schemeClr val="phClr">
+                <a:lumMod val="99000"/>
+                <a:satMod val="120000"/>
+                <a:shade val="78000"/>
+              </a:schemeClr>
+            </a:gs>
+          </a:gsLst>
+          <a:lin ang="5400000" scaled="0"/>
+        </a:gradFill>
+      </a:fillStyleLst>
+      <a:lnStyleLst>
+        <a:ln w="12700" cap="flat" cmpd="sng" algn="ctr">
+          <a:solidFill>
+            <a:schemeClr val="phClr"/>
+          </a:solidFill>
+          <a:prstDash val="solid"/>
+          <a:miter lim="800000"/>
+        </a:ln>
+        <a:ln w="19050" cap="flat" cmpd="sng" algn="ctr">
+          <a:solidFill>
+            <a:schemeClr val="phClr"/>
+          </a:solidFill>
+          <a:prstDash val="solid"/>
+          <a:miter lim="800000"/>
+        </a:ln>
+        <a:ln w="25400" cap="flat" cmpd="sng" algn="ctr">
+          <a:solidFill>
+            <a:schemeClr val="phClr"/>
+          </a:solidFill>
+          <a:prstDash val="solid"/>
+          <a:miter lim="800000"/>
+        </a:ln>
+      </a:lnStyleLst>
+      <a:effectStyleLst>
+        <a:effectStyle>
+          <a:effectLst/>
+        </a:effectStyle>
+        <a:effectStyle>
+          <a:effectLst/>
+        </a:effectStyle>
+        <a:effectStyle>
+          <a:effectLst>
+            <a:outerShdw blurRad="57150" dist="19050" dir="5400000" algn="ctr" rotWithShape="0">
+              <a:srgbClr val="000000">
+                <a:alpha val="63000"/>
+              </a:srgbClr>
+            </a:outerShdw>
+          </a:effectLst>
+        </a:effectStyle>
+      </a:effectStyleLst>
+      <a:bgFillStyleLst>
+        <a:solidFill>
+          <a:schemeClr val="phClr"/>
+        </a:solidFill>
+        <a:solidFill>
+          <a:schemeClr val="phClr">
+            <a:tint val="95000"/>
+            <a:satMod val="170000"/>
+          </a:schemeClr>
+        </a:solidFill>
+        <a:gradFill rotWithShape="1">
+          <a:gsLst>
+            <a:gs pos="0">
+              <a:schemeClr val="phClr">
+                <a:tint val="93000"/>
+                <a:satMod val="150000"/>
+                <a:shade val="98000"/>
+                <a:lumMod val="102000"/>
+              </a:schemeClr>
+            </a:gs>
+            <a:gs pos="50000">
+              <a:schemeClr val="phClr">
+                <a:tint val="98000"/>
+                <a:satMod val="130000"/>
+                <a:shade val="90000"/>
+                <a:lumMod val="103000"/>
+              </a:schemeClr>
+            </a:gs>
+            <a:gs pos="100000">
+              <a:schemeClr val="phClr">
+                <a:shade val="63000"/>
+                <a:satMod val="120000"/>
+              </a:schemeClr>
+            </a:gs>
+          </a:gsLst>
+          <a:lin ang="5400000" scaled="0"/>
+        </a:gradFill>
+      </a:bgFillStyleLst>
+    </a:fmtScheme>
+  </a:themeElements>
+  <a:objectDefaults>
+    <a:lnDef>
+      <a:spPr/>
+      <a:bodyPr/>
+      <a:lstStyle/>
+      <a:style>
+        <a:lnRef idx="2">
+          <a:schemeClr val="accent1"/>
+        </a:lnRef>
+        <a:fillRef idx="0">
+          <a:schemeClr val="accent1"/>
+        </a:fillRef>
+        <a:effectRef idx="1">
+          <a:schemeClr val="accent1"/>
+        </a:effectRef>
+        <a:fontRef idx="minor">
+          <a:schemeClr val="tx1"/>
+        </a:fontRef>
+      </a:style>
+    </a:lnDef>
+  </a:objectDefaults>
+  <a:extraClrSchemeLst/>
+  <a:extLst>
+    <a:ext uri="{05A4C25C-085E-4340-85A3-A5531E510DB2}">
+      <thm15:themeFamily xmlns:thm15="http://schemas.microsoft.com/office/thememl/2012/main" name="Office Theme" id="{2E142A2C-CD16-42D6-873A-C26D2A0506FA}" vid="{1BDDFF52-6CD6-40A5-AB3C-68EB2F1E4D0A}"/>
+    </a:ext>
+  </a:extLst>
+</a:theme>
 </file>
</xml_diff>